<commit_message>
docs: added pcb export - buck_5V1
</commit_message>
<xml_diff>
--- a/docs/uni-submission/end-semester-one.pptx
+++ b/docs/uni-submission/end-semester-one.pptx
@@ -50,7 +50,7 @@
         <p:spPr>
           <a:xfrm>
             <a:off x="0" y="5400000"/>
-            <a:ext cx="10080000" cy="270000"/>
+            <a:ext cx="10079640" cy="269640"/>
           </a:xfrm>
           <a:prstGeom prst="rect">
             <a:avLst/>
@@ -73,6 +73,11 @@
             <a:spAutoFit/>
           </a:bodyPr>
           <a:p>
+            <a:pPr>
+              <a:lnSpc>
+                <a:spcPct val="100000"/>
+              </a:lnSpc>
+            </a:pPr>
             <a:endParaRPr lang="en-GB" sz="1400" b="1" u="none" strike="noStrike">
               <a:solidFill>
                 <a:srgbClr val="ffffff"/>
@@ -80,6 +85,7 @@
               <a:effectLst/>
               <a:uFillTx/>
               <a:latin typeface="Noto Sans"/>
+              <a:ea typeface="DejaVu Sans"/>
             </a:endParaRPr>
           </a:p>
         </p:txBody>
@@ -93,7 +99,7 @@
         <p:spPr>
           <a:xfrm>
             <a:off x="0" y="0"/>
-            <a:ext cx="10080000" cy="1215000"/>
+            <a:ext cx="10079640" cy="1214640"/>
           </a:xfrm>
           <a:prstGeom prst="rect">
             <a:avLst/>
@@ -116,6 +122,11 @@
             <a:spAutoFit/>
           </a:bodyPr>
           <a:p>
+            <a:pPr>
+              <a:lnSpc>
+                <a:spcPct val="100000"/>
+              </a:lnSpc>
+            </a:pPr>
             <a:endParaRPr lang="en-GB" sz="1400" b="1" u="none" strike="noStrike">
               <a:solidFill>
                 <a:srgbClr val="ffffff"/>
@@ -123,6 +134,7 @@
               <a:effectLst/>
               <a:uFillTx/>
               <a:latin typeface="Noto Sans"/>
+              <a:ea typeface="DejaVu Sans"/>
             </a:endParaRPr>
           </a:p>
         </p:txBody>
@@ -136,7 +148,7 @@
         <p:spPr>
           <a:xfrm>
             <a:off x="9315000" y="5175000"/>
-            <a:ext cx="450000" cy="450000"/>
+            <a:ext cx="449640" cy="449640"/>
           </a:xfrm>
           <a:prstGeom prst="ellipse">
             <a:avLst/>
@@ -161,6 +173,11 @@
             <a:spAutoFit/>
           </a:bodyPr>
           <a:p>
+            <a:pPr>
+              <a:lnSpc>
+                <a:spcPct val="100000"/>
+              </a:lnSpc>
+            </a:pPr>
             <a:endParaRPr lang="en-GB" sz="1400" b="1" u="none" strike="noStrike">
               <a:solidFill>
                 <a:srgbClr val="ffffff"/>
@@ -168,6 +185,7 @@
               <a:effectLst/>
               <a:uFillTx/>
               <a:latin typeface="Noto Sans"/>
+              <a:ea typeface="DejaVu Sans"/>
             </a:endParaRPr>
           </a:p>
         </p:txBody>
@@ -185,7 +203,7 @@
         <p:spPr>
           <a:xfrm>
             <a:off x="360000" y="225720"/>
-            <a:ext cx="9360000" cy="718920"/>
+            <a:ext cx="9359640" cy="718560"/>
           </a:xfrm>
           <a:prstGeom prst="rect">
             <a:avLst/>
@@ -201,7 +219,13 @@
           </a:bodyPr>
           <a:p>
             <a:pPr indent="0">
+              <a:lnSpc>
+                <a:spcPct val="100000"/>
+              </a:lnSpc>
               <a:buNone/>
+              <a:tabLst>
+                <a:tab algn="l" pos="0"/>
+              </a:tabLst>
             </a:pPr>
             <a:r>
               <a:rPr lang="en-GB" sz="3200" b="1" u="none" strike="noStrike">
@@ -212,15 +236,26 @@
                 <a:uFillTx/>
                 <a:latin typeface="Noto Sans"/>
               </a:rPr>
-              <a:t>Click to edit the title text format</a:t>
-            </a:r>
-            <a:endParaRPr lang="en-GB" sz="3200" b="1" u="none" strike="noStrike">
-              <a:solidFill>
-                <a:srgbClr val="ffffff"/>
-              </a:solidFill>
-              <a:effectLst/>
-              <a:uFillTx/>
-              <a:latin typeface="Noto Sans"/>
+              <a:t>Click to edit the </a:t>
+            </a:r>
+            <a:r>
+              <a:rPr lang="en-GB" sz="3200" b="1" u="none" strike="noStrike">
+                <a:solidFill>
+                  <a:srgbClr val="ffffff"/>
+                </a:solidFill>
+                <a:effectLst/>
+                <a:uFillTx/>
+                <a:latin typeface="Noto Sans"/>
+              </a:rPr>
+              <a:t>title text format</a:t>
+            </a:r>
+            <a:endParaRPr lang="en-GB" sz="3200" b="0" u="none" strike="noStrike">
+              <a:solidFill>
+                <a:srgbClr val="000000"/>
+              </a:solidFill>
+              <a:effectLst/>
+              <a:uFillTx/>
+              <a:latin typeface="Arial"/>
             </a:endParaRPr>
           </a:p>
         </p:txBody>
@@ -238,7 +273,7 @@
         <p:spPr>
           <a:xfrm>
             <a:off x="360000" y="1485000"/>
-            <a:ext cx="9360000" cy="3780000"/>
+            <a:ext cx="9359640" cy="3779640"/>
           </a:xfrm>
           <a:prstGeom prst="rect">
             <a:avLst/>
@@ -254,6 +289,9 @@
           </a:bodyPr>
           <a:p>
             <a:pPr marL="432000" indent="-324000">
+              <a:lnSpc>
+                <a:spcPct val="100000"/>
+              </a:lnSpc>
               <a:spcAft>
                 <a:spcPts val="1057"/>
               </a:spcAft>
@@ -275,17 +313,20 @@
               </a:rPr>
               <a:t>Click to edit the outline text format</a:t>
             </a:r>
-            <a:endParaRPr lang="en-GB" sz="2400" b="1" u="none" strike="noStrike">
-              <a:solidFill>
-                <a:srgbClr val="2c3e50"/>
-              </a:solidFill>
-              <a:effectLst/>
-              <a:uFillTx/>
-              <a:latin typeface="Noto Sans"/>
+            <a:endParaRPr lang="en-GB" sz="2400" b="0" u="none" strike="noStrike">
+              <a:solidFill>
+                <a:srgbClr val="000000"/>
+              </a:solidFill>
+              <a:effectLst/>
+              <a:uFillTx/>
+              <a:latin typeface="Arial"/>
             </a:endParaRPr>
           </a:p>
           <a:p>
             <a:pPr marL="864000" lvl="1" indent="-324000">
+              <a:lnSpc>
+                <a:spcPct val="100000"/>
+              </a:lnSpc>
               <a:spcAft>
                 <a:spcPts val="850"/>
               </a:spcAft>
@@ -309,15 +350,18 @@
             </a:r>
             <a:endParaRPr lang="en-GB" sz="2100" b="0" u="none" strike="noStrike">
               <a:solidFill>
-                <a:srgbClr val="2c3e50"/>
-              </a:solidFill>
-              <a:effectLst/>
-              <a:uFillTx/>
-              <a:latin typeface="Noto Sans"/>
+                <a:srgbClr val="000000"/>
+              </a:solidFill>
+              <a:effectLst/>
+              <a:uFillTx/>
+              <a:latin typeface="Arial"/>
             </a:endParaRPr>
           </a:p>
           <a:p>
             <a:pPr marL="1296000" lvl="2" indent="-288000">
+              <a:lnSpc>
+                <a:spcPct val="100000"/>
+              </a:lnSpc>
               <a:spcAft>
                 <a:spcPts val="635"/>
               </a:spcAft>
@@ -341,15 +385,18 @@
             </a:r>
             <a:endParaRPr lang="en-GB" sz="1800" b="0" u="none" strike="noStrike">
               <a:solidFill>
-                <a:srgbClr val="2c3e50"/>
-              </a:solidFill>
-              <a:effectLst/>
-              <a:uFillTx/>
-              <a:latin typeface="Noto Sans"/>
+                <a:srgbClr val="000000"/>
+              </a:solidFill>
+              <a:effectLst/>
+              <a:uFillTx/>
+              <a:latin typeface="Arial"/>
             </a:endParaRPr>
           </a:p>
           <a:p>
             <a:pPr marL="1728000" lvl="3" indent="-216000">
+              <a:lnSpc>
+                <a:spcPct val="100000"/>
+              </a:lnSpc>
               <a:spcAft>
                 <a:spcPts val="425"/>
               </a:spcAft>
@@ -373,15 +420,18 @@
             </a:r>
             <a:endParaRPr lang="en-GB" sz="1500" b="0" u="none" strike="noStrike">
               <a:solidFill>
-                <a:srgbClr val="2c3e50"/>
-              </a:solidFill>
-              <a:effectLst/>
-              <a:uFillTx/>
-              <a:latin typeface="Noto Sans"/>
+                <a:srgbClr val="000000"/>
+              </a:solidFill>
+              <a:effectLst/>
+              <a:uFillTx/>
+              <a:latin typeface="Arial"/>
             </a:endParaRPr>
           </a:p>
           <a:p>
             <a:pPr marL="2160000" lvl="4" indent="-216000">
+              <a:lnSpc>
+                <a:spcPct val="100000"/>
+              </a:lnSpc>
               <a:spcAft>
                 <a:spcPts val="213"/>
               </a:spcAft>
@@ -405,15 +455,18 @@
             </a:r>
             <a:endParaRPr lang="en-GB" sz="1500" b="0" u="none" strike="noStrike">
               <a:solidFill>
-                <a:srgbClr val="2c3e50"/>
-              </a:solidFill>
-              <a:effectLst/>
-              <a:uFillTx/>
-              <a:latin typeface="Noto Sans"/>
+                <a:srgbClr val="000000"/>
+              </a:solidFill>
+              <a:effectLst/>
+              <a:uFillTx/>
+              <a:latin typeface="Arial"/>
             </a:endParaRPr>
           </a:p>
           <a:p>
             <a:pPr marL="2592000" lvl="5" indent="-216000">
+              <a:lnSpc>
+                <a:spcPct val="100000"/>
+              </a:lnSpc>
               <a:spcAft>
                 <a:spcPts val="213"/>
               </a:spcAft>
@@ -437,15 +490,18 @@
             </a:r>
             <a:endParaRPr lang="en-GB" sz="1500" b="0" u="none" strike="noStrike">
               <a:solidFill>
-                <a:srgbClr val="2c3e50"/>
-              </a:solidFill>
-              <a:effectLst/>
-              <a:uFillTx/>
-              <a:latin typeface="Noto Sans"/>
+                <a:srgbClr val="000000"/>
+              </a:solidFill>
+              <a:effectLst/>
+              <a:uFillTx/>
+              <a:latin typeface="Arial"/>
             </a:endParaRPr>
           </a:p>
           <a:p>
             <a:pPr marL="3024000" lvl="6" indent="-216000">
+              <a:lnSpc>
+                <a:spcPct val="100000"/>
+              </a:lnSpc>
               <a:spcAft>
                 <a:spcPts val="213"/>
               </a:spcAft>
@@ -469,11 +525,11 @@
             </a:r>
             <a:endParaRPr lang="en-GB" sz="1500" b="0" u="none" strike="noStrike">
               <a:solidFill>
-                <a:srgbClr val="2c3e50"/>
-              </a:solidFill>
-              <a:effectLst/>
-              <a:uFillTx/>
-              <a:latin typeface="Noto Sans"/>
+                <a:srgbClr val="000000"/>
+              </a:solidFill>
+              <a:effectLst/>
+              <a:uFillTx/>
+              <a:latin typeface="Arial"/>
             </a:endParaRPr>
           </a:p>
         </p:txBody>
@@ -491,7 +547,7 @@
         <p:spPr>
           <a:xfrm>
             <a:off x="360000" y="5400000"/>
-            <a:ext cx="2880000" cy="311400"/>
+            <a:ext cx="2879640" cy="311400"/>
           </a:xfrm>
           <a:prstGeom prst="rect">
             <a:avLst/>
@@ -507,7 +563,13 @@
           </a:bodyPr>
           <a:lstStyle>
             <a:lvl1pPr indent="0">
+              <a:lnSpc>
+                <a:spcPct val="100000"/>
+              </a:lnSpc>
               <a:buNone/>
+              <a:tabLst>
+                <a:tab algn="l" pos="0"/>
+              </a:tabLst>
               <a:defRPr lang="en-GB" sz="1800" b="1" u="none" strike="noStrike">
                 <a:solidFill>
                   <a:srgbClr val="ffffff"/>
@@ -520,7 +582,13 @@
           </a:lstStyle>
           <a:p>
             <a:pPr indent="0">
+              <a:lnSpc>
+                <a:spcPct val="100000"/>
+              </a:lnSpc>
               <a:buNone/>
+              <a:tabLst>
+                <a:tab algn="l" pos="0"/>
+              </a:tabLst>
             </a:pPr>
             <a:r>
               <a:rPr lang="en-GB" sz="1800" b="1" u="none" strike="noStrike">
@@ -533,13 +601,13 @@
               </a:rPr>
               <a:t>&lt;date/time&gt;</a:t>
             </a:r>
-            <a:endParaRPr lang="en-GB" sz="1800" b="1" u="none" strike="noStrike">
-              <a:solidFill>
-                <a:srgbClr val="ffffff"/>
-              </a:solidFill>
-              <a:effectLst/>
-              <a:uFillTx/>
-              <a:latin typeface="Noto Sans"/>
+            <a:endParaRPr lang="en-GB" sz="1800" b="0" u="none" strike="noStrike">
+              <a:solidFill>
+                <a:srgbClr val="000000"/>
+              </a:solidFill>
+              <a:effectLst/>
+              <a:uFillTx/>
+              <a:latin typeface="Times New Roman"/>
             </a:endParaRPr>
           </a:p>
         </p:txBody>
@@ -557,7 +625,7 @@
         <p:spPr>
           <a:xfrm>
             <a:off x="3420000" y="5400000"/>
-            <a:ext cx="3240000" cy="311400"/>
+            <a:ext cx="3239640" cy="311400"/>
           </a:xfrm>
           <a:prstGeom prst="rect">
             <a:avLst/>
@@ -573,7 +641,13 @@
           </a:bodyPr>
           <a:lstStyle>
             <a:lvl1pPr indent="0" algn="ctr">
+              <a:lnSpc>
+                <a:spcPct val="100000"/>
+              </a:lnSpc>
               <a:buNone/>
+              <a:tabLst>
+                <a:tab algn="l" pos="0"/>
+              </a:tabLst>
               <a:defRPr lang="en-GB" sz="1800" b="1" u="none" strike="noStrike">
                 <a:solidFill>
                   <a:srgbClr val="ffffff"/>
@@ -586,7 +660,13 @@
           </a:lstStyle>
           <a:p>
             <a:pPr indent="0" algn="ctr">
+              <a:lnSpc>
+                <a:spcPct val="100000"/>
+              </a:lnSpc>
               <a:buNone/>
+              <a:tabLst>
+                <a:tab algn="l" pos="0"/>
+              </a:tabLst>
             </a:pPr>
             <a:r>
               <a:rPr lang="en-GB" sz="1800" b="1" u="none" strike="noStrike">
@@ -599,13 +679,13 @@
               </a:rPr>
               <a:t>&lt;footer&gt;</a:t>
             </a:r>
-            <a:endParaRPr lang="en-GB" sz="1800" b="1" u="none" strike="noStrike">
-              <a:solidFill>
-                <a:srgbClr val="ffffff"/>
-              </a:solidFill>
-              <a:effectLst/>
-              <a:uFillTx/>
-              <a:latin typeface="Noto Sans"/>
+            <a:endParaRPr lang="en-GB" sz="1800" b="0" u="none" strike="noStrike">
+              <a:solidFill>
+                <a:srgbClr val="000000"/>
+              </a:solidFill>
+              <a:effectLst/>
+              <a:uFillTx/>
+              <a:latin typeface="Times New Roman"/>
             </a:endParaRPr>
           </a:p>
         </p:txBody>
@@ -622,8 +702,8 @@
         </p:nvSpPr>
         <p:spPr>
           <a:xfrm>
-            <a:off x="9180000" y="5175000"/>
-            <a:ext cx="720000" cy="450000"/>
+            <a:off x="9180000" y="5262480"/>
+            <a:ext cx="719640" cy="274680"/>
           </a:xfrm>
           <a:prstGeom prst="rect">
             <a:avLst/>
@@ -639,7 +719,13 @@
           </a:bodyPr>
           <a:lstStyle>
             <a:lvl1pPr indent="0" algn="ctr">
+              <a:lnSpc>
+                <a:spcPct val="100000"/>
+              </a:lnSpc>
               <a:buNone/>
+              <a:tabLst>
+                <a:tab algn="l" pos="0"/>
+              </a:tabLst>
               <a:defRPr lang="en-GB" sz="1800" b="1" u="none" strike="noStrike">
                 <a:solidFill>
                   <a:srgbClr val="ffffff"/>
@@ -652,9 +738,15 @@
           </a:lstStyle>
           <a:p>
             <a:pPr indent="0" algn="ctr">
+              <a:lnSpc>
+                <a:spcPct val="100000"/>
+              </a:lnSpc>
               <a:buNone/>
-            </a:pPr>
-            <a:fld id="{83C045B1-C0F7-45BB-B73D-637CF7C671B9}" type="slidenum">
+              <a:tabLst>
+                <a:tab algn="l" pos="0"/>
+              </a:tabLst>
+            </a:pPr>
+            <a:fld id="{475168E3-74F1-4CF9-BC74-D25E713E963A}" type="slidenum">
               <a:rPr lang="en-GB" sz="1800" b="1" u="none" strike="noStrike">
                 <a:solidFill>
                   <a:srgbClr val="ffffff"/>
@@ -665,13 +757,13 @@
               </a:rPr>
               <a:t>&lt;number&gt;</a:t>
             </a:fld>
-            <a:endParaRPr lang="en-GB" sz="1800" b="1" u="none" strike="noStrike">
-              <a:solidFill>
-                <a:srgbClr val="ffffff"/>
-              </a:solidFill>
-              <a:effectLst/>
-              <a:uFillTx/>
-              <a:latin typeface="Noto Sans"/>
+            <a:endParaRPr lang="en-GB" sz="1800" b="0" u="none" strike="noStrike">
+              <a:solidFill>
+                <a:srgbClr val="000000"/>
+              </a:solidFill>
+              <a:effectLst/>
+              <a:uFillTx/>
+              <a:latin typeface="Times New Roman"/>
             </a:endParaRPr>
           </a:p>
         </p:txBody>
@@ -707,7 +799,7 @@
         <p:spPr>
           <a:xfrm>
             <a:off x="0" y="0"/>
-            <a:ext cx="10080000" cy="5670000"/>
+            <a:ext cx="10079640" cy="5669640"/>
           </a:xfrm>
           <a:prstGeom prst="rect">
             <a:avLst/>
@@ -730,6 +822,11 @@
             <a:spAutoFit/>
           </a:bodyPr>
           <a:p>
+            <a:pPr>
+              <a:lnSpc>
+                <a:spcPct val="100000"/>
+              </a:lnSpc>
+            </a:pPr>
             <a:endParaRPr lang="en-GB" sz="1400" b="1" u="none" strike="noStrike">
               <a:solidFill>
                 <a:srgbClr val="ffffff"/>
@@ -737,6 +834,7 @@
               <a:effectLst/>
               <a:uFillTx/>
               <a:latin typeface="Noto Sans"/>
+              <a:ea typeface="DejaVu Sans"/>
             </a:endParaRPr>
           </a:p>
         </p:txBody>
@@ -750,7 +848,7 @@
         <p:spPr>
           <a:xfrm>
             <a:off x="0" y="0"/>
-            <a:ext cx="10080000" cy="3780000"/>
+            <a:ext cx="10079640" cy="3779640"/>
           </a:xfrm>
           <a:prstGeom prst="rect">
             <a:avLst/>
@@ -775,6 +873,11 @@
             <a:spAutoFit/>
           </a:bodyPr>
           <a:p>
+            <a:pPr>
+              <a:lnSpc>
+                <a:spcPct val="100000"/>
+              </a:lnSpc>
+            </a:pPr>
             <a:endParaRPr lang="en-GB" sz="1400" b="1" u="none" strike="noStrike">
               <a:solidFill>
                 <a:srgbClr val="ffffff"/>
@@ -782,6 +885,7 @@
               <a:effectLst/>
               <a:uFillTx/>
               <a:latin typeface="Noto Sans"/>
+              <a:ea typeface="DejaVu Sans"/>
             </a:endParaRPr>
           </a:p>
         </p:txBody>
@@ -799,7 +903,7 @@
         <p:spPr>
           <a:xfrm>
             <a:off x="360000" y="2835000"/>
-            <a:ext cx="9360000" cy="718920"/>
+            <a:ext cx="9359640" cy="718560"/>
           </a:xfrm>
           <a:prstGeom prst="rect">
             <a:avLst/>
@@ -815,7 +919,13 @@
           </a:bodyPr>
           <a:p>
             <a:pPr indent="0" algn="ctr">
+              <a:lnSpc>
+                <a:spcPct val="100000"/>
+              </a:lnSpc>
               <a:buNone/>
+              <a:tabLst>
+                <a:tab algn="l" pos="0"/>
+              </a:tabLst>
             </a:pPr>
             <a:r>
               <a:rPr lang="en-GB" sz="3200" b="1" u="none" strike="noStrike">
@@ -828,13 +938,13 @@
               </a:rPr>
               <a:t>Click to edit the title text format</a:t>
             </a:r>
-            <a:endParaRPr lang="en-GB" sz="3200" b="1" u="none" strike="noStrike">
-              <a:solidFill>
-                <a:srgbClr val="ffffff"/>
-              </a:solidFill>
-              <a:effectLst/>
-              <a:uFillTx/>
-              <a:latin typeface="Noto Sans"/>
+            <a:endParaRPr lang="en-GB" sz="3200" b="0" u="none" strike="noStrike">
+              <a:solidFill>
+                <a:srgbClr val="000000"/>
+              </a:solidFill>
+              <a:effectLst/>
+              <a:uFillTx/>
+              <a:latin typeface="Arial"/>
             </a:endParaRPr>
           </a:p>
         </p:txBody>
@@ -852,7 +962,7 @@
         <p:spPr>
           <a:xfrm>
             <a:off x="360000" y="3915000"/>
-            <a:ext cx="9360000" cy="1485000"/>
+            <a:ext cx="9359640" cy="1484640"/>
           </a:xfrm>
           <a:prstGeom prst="rect">
             <a:avLst/>
@@ -864,13 +974,20 @@
         </p:spPr>
         <p:txBody>
           <a:bodyPr lIns="0" rIns="0" tIns="0" bIns="0" anchor="t">
-            <a:normAutofit fontScale="77500" lnSpcReduction="19999"/>
+            <a:normAutofit fontScale="85000" lnSpcReduction="19999"/>
           </a:bodyPr>
           <a:p>
             <a:pPr marL="432000" indent="0">
+              <a:lnSpc>
+                <a:spcPct val="100000"/>
+              </a:lnSpc>
               <a:spcAft>
                 <a:spcPts val="655"/>
               </a:spcAft>
+              <a:buNone/>
+              <a:tabLst>
+                <a:tab algn="l" pos="0"/>
+              </a:tabLst>
             </a:pPr>
             <a:r>
               <a:rPr lang="en-GB" sz="1500" b="0" u="none" strike="noStrike">
@@ -885,18 +1002,25 @@
             </a:r>
             <a:endParaRPr lang="en-GB" sz="1500" b="0" u="none" strike="noStrike">
               <a:solidFill>
-                <a:srgbClr val="ffffff"/>
-              </a:solidFill>
-              <a:effectLst/>
-              <a:uFillTx/>
-              <a:latin typeface="Noto Sans"/>
-            </a:endParaRPr>
-          </a:p>
-          <a:p>
-            <a:pPr marL="864000" lvl="1" indent="0">
+                <a:srgbClr val="000000"/>
+              </a:solidFill>
+              <a:effectLst/>
+              <a:uFillTx/>
+              <a:latin typeface="Arial"/>
+            </a:endParaRPr>
+          </a:p>
+          <a:p>
+            <a:pPr marL="864000" indent="0">
+              <a:lnSpc>
+                <a:spcPct val="100000"/>
+              </a:lnSpc>
               <a:spcAft>
                 <a:spcPts val="850"/>
               </a:spcAft>
+              <a:buNone/>
+              <a:tabLst>
+                <a:tab algn="l" pos="0"/>
+              </a:tabLst>
             </a:pPr>
             <a:r>
               <a:rPr lang="en-GB" sz="1500" b="0" u="none" strike="noStrike">
@@ -911,18 +1035,25 @@
             </a:r>
             <a:endParaRPr lang="en-GB" sz="1500" b="0" u="none" strike="noStrike">
               <a:solidFill>
-                <a:srgbClr val="ffffff"/>
-              </a:solidFill>
-              <a:effectLst/>
-              <a:uFillTx/>
-              <a:latin typeface="Noto Sans"/>
-            </a:endParaRPr>
-          </a:p>
-          <a:p>
-            <a:pPr marL="1296000" lvl="2" indent="0">
+                <a:srgbClr val="000000"/>
+              </a:solidFill>
+              <a:effectLst/>
+              <a:uFillTx/>
+              <a:latin typeface="Arial"/>
+            </a:endParaRPr>
+          </a:p>
+          <a:p>
+            <a:pPr marL="1296000" indent="0">
+              <a:lnSpc>
+                <a:spcPct val="100000"/>
+              </a:lnSpc>
               <a:spcAft>
                 <a:spcPts val="635"/>
               </a:spcAft>
+              <a:buNone/>
+              <a:tabLst>
+                <a:tab algn="l" pos="0"/>
+              </a:tabLst>
             </a:pPr>
             <a:r>
               <a:rPr lang="en-GB" sz="1500" b="0" u="none" strike="noStrike">
@@ -937,18 +1068,25 @@
             </a:r>
             <a:endParaRPr lang="en-GB" sz="1500" b="0" u="none" strike="noStrike">
               <a:solidFill>
-                <a:srgbClr val="ffffff"/>
-              </a:solidFill>
-              <a:effectLst/>
-              <a:uFillTx/>
-              <a:latin typeface="Noto Sans"/>
-            </a:endParaRPr>
-          </a:p>
-          <a:p>
-            <a:pPr marL="1728000" lvl="3" indent="0">
+                <a:srgbClr val="000000"/>
+              </a:solidFill>
+              <a:effectLst/>
+              <a:uFillTx/>
+              <a:latin typeface="Arial"/>
+            </a:endParaRPr>
+          </a:p>
+          <a:p>
+            <a:pPr marL="1728000" indent="0">
+              <a:lnSpc>
+                <a:spcPct val="100000"/>
+              </a:lnSpc>
               <a:spcAft>
                 <a:spcPts val="425"/>
               </a:spcAft>
+              <a:buNone/>
+              <a:tabLst>
+                <a:tab algn="l" pos="0"/>
+              </a:tabLst>
             </a:pPr>
             <a:r>
               <a:rPr lang="en-GB" sz="1500" b="0" u="none" strike="noStrike">
@@ -963,18 +1101,25 @@
             </a:r>
             <a:endParaRPr lang="en-GB" sz="1500" b="0" u="none" strike="noStrike">
               <a:solidFill>
-                <a:srgbClr val="ffffff"/>
-              </a:solidFill>
-              <a:effectLst/>
-              <a:uFillTx/>
-              <a:latin typeface="Noto Sans"/>
-            </a:endParaRPr>
-          </a:p>
-          <a:p>
-            <a:pPr marL="2160000" lvl="4" indent="0">
+                <a:srgbClr val="000000"/>
+              </a:solidFill>
+              <a:effectLst/>
+              <a:uFillTx/>
+              <a:latin typeface="Arial"/>
+            </a:endParaRPr>
+          </a:p>
+          <a:p>
+            <a:pPr marL="2160000" indent="0">
+              <a:lnSpc>
+                <a:spcPct val="100000"/>
+              </a:lnSpc>
               <a:spcAft>
                 <a:spcPts val="213"/>
               </a:spcAft>
+              <a:buNone/>
+              <a:tabLst>
+                <a:tab algn="l" pos="0"/>
+              </a:tabLst>
             </a:pPr>
             <a:r>
               <a:rPr lang="en-GB" sz="1500" b="0" u="none" strike="noStrike">
@@ -989,18 +1134,25 @@
             </a:r>
             <a:endParaRPr lang="en-GB" sz="1500" b="0" u="none" strike="noStrike">
               <a:solidFill>
-                <a:srgbClr val="ffffff"/>
-              </a:solidFill>
-              <a:effectLst/>
-              <a:uFillTx/>
-              <a:latin typeface="Noto Sans"/>
-            </a:endParaRPr>
-          </a:p>
-          <a:p>
-            <a:pPr marL="2592000" lvl="5" indent="0">
+                <a:srgbClr val="000000"/>
+              </a:solidFill>
+              <a:effectLst/>
+              <a:uFillTx/>
+              <a:latin typeface="Arial"/>
+            </a:endParaRPr>
+          </a:p>
+          <a:p>
+            <a:pPr marL="2592000" indent="0">
+              <a:lnSpc>
+                <a:spcPct val="100000"/>
+              </a:lnSpc>
               <a:spcAft>
                 <a:spcPts val="213"/>
               </a:spcAft>
+              <a:buNone/>
+              <a:tabLst>
+                <a:tab algn="l" pos="0"/>
+              </a:tabLst>
             </a:pPr>
             <a:r>
               <a:rPr lang="en-GB" sz="1500" b="0" u="none" strike="noStrike">
@@ -1015,18 +1167,25 @@
             </a:r>
             <a:endParaRPr lang="en-GB" sz="1500" b="0" u="none" strike="noStrike">
               <a:solidFill>
-                <a:srgbClr val="ffffff"/>
-              </a:solidFill>
-              <a:effectLst/>
-              <a:uFillTx/>
-              <a:latin typeface="Noto Sans"/>
-            </a:endParaRPr>
-          </a:p>
-          <a:p>
-            <a:pPr marL="3024000" lvl="6" indent="0">
+                <a:srgbClr val="000000"/>
+              </a:solidFill>
+              <a:effectLst/>
+              <a:uFillTx/>
+              <a:latin typeface="Arial"/>
+            </a:endParaRPr>
+          </a:p>
+          <a:p>
+            <a:pPr marL="3024000" indent="0">
+              <a:lnSpc>
+                <a:spcPct val="100000"/>
+              </a:lnSpc>
               <a:spcAft>
                 <a:spcPts val="213"/>
               </a:spcAft>
+              <a:buNone/>
+              <a:tabLst>
+                <a:tab algn="l" pos="0"/>
+              </a:tabLst>
             </a:pPr>
             <a:r>
               <a:rPr lang="en-GB" sz="1500" b="0" u="none" strike="noStrike">
@@ -1041,11 +1200,11 @@
             </a:r>
             <a:endParaRPr lang="en-GB" sz="1500" b="0" u="none" strike="noStrike">
               <a:solidFill>
-                <a:srgbClr val="ffffff"/>
-              </a:solidFill>
-              <a:effectLst/>
-              <a:uFillTx/>
-              <a:latin typeface="Noto Sans"/>
+                <a:srgbClr val="000000"/>
+              </a:solidFill>
+              <a:effectLst/>
+              <a:uFillTx/>
+              <a:latin typeface="Arial"/>
             </a:endParaRPr>
           </a:p>
         </p:txBody>
@@ -1063,7 +1222,7 @@
         <p:spPr>
           <a:xfrm>
             <a:off x="360000" y="5400000"/>
-            <a:ext cx="2880000" cy="311400"/>
+            <a:ext cx="2879640" cy="311400"/>
           </a:xfrm>
           <a:prstGeom prst="rect">
             <a:avLst/>
@@ -1079,7 +1238,13 @@
           </a:bodyPr>
           <a:lstStyle>
             <a:lvl1pPr indent="0">
+              <a:lnSpc>
+                <a:spcPct val="100000"/>
+              </a:lnSpc>
               <a:buNone/>
+              <a:tabLst>
+                <a:tab algn="l" pos="0"/>
+              </a:tabLst>
               <a:defRPr lang="en-GB" sz="1800" b="1" u="none" strike="noStrike">
                 <a:solidFill>
                   <a:srgbClr val="ffffff"/>
@@ -1092,7 +1257,13 @@
           </a:lstStyle>
           <a:p>
             <a:pPr indent="0">
+              <a:lnSpc>
+                <a:spcPct val="100000"/>
+              </a:lnSpc>
               <a:buNone/>
+              <a:tabLst>
+                <a:tab algn="l" pos="0"/>
+              </a:tabLst>
             </a:pPr>
             <a:r>
               <a:rPr lang="en-GB" sz="1800" b="1" u="none" strike="noStrike">
@@ -1105,13 +1276,13 @@
               </a:rPr>
               <a:t>&lt;date/time&gt;</a:t>
             </a:r>
-            <a:endParaRPr lang="en-GB" sz="1800" b="1" u="none" strike="noStrike">
-              <a:solidFill>
-                <a:srgbClr val="ffffff"/>
-              </a:solidFill>
-              <a:effectLst/>
-              <a:uFillTx/>
-              <a:latin typeface="Noto Sans"/>
+            <a:endParaRPr lang="en-GB" sz="1800" b="0" u="none" strike="noStrike">
+              <a:solidFill>
+                <a:srgbClr val="000000"/>
+              </a:solidFill>
+              <a:effectLst/>
+              <a:uFillTx/>
+              <a:latin typeface="Times New Roman"/>
             </a:endParaRPr>
           </a:p>
         </p:txBody>
@@ -1129,7 +1300,7 @@
         <p:spPr>
           <a:xfrm>
             <a:off x="3420000" y="5400000"/>
-            <a:ext cx="3240000" cy="311400"/>
+            <a:ext cx="3239640" cy="311400"/>
           </a:xfrm>
           <a:prstGeom prst="rect">
             <a:avLst/>
@@ -1145,7 +1316,13 @@
           </a:bodyPr>
           <a:lstStyle>
             <a:lvl1pPr indent="0" algn="ctr">
+              <a:lnSpc>
+                <a:spcPct val="100000"/>
+              </a:lnSpc>
               <a:buNone/>
+              <a:tabLst>
+                <a:tab algn="l" pos="0"/>
+              </a:tabLst>
               <a:defRPr lang="en-GB" sz="1800" b="1" u="none" strike="noStrike">
                 <a:solidFill>
                   <a:srgbClr val="ffffff"/>
@@ -1158,7 +1335,13 @@
           </a:lstStyle>
           <a:p>
             <a:pPr indent="0" algn="ctr">
+              <a:lnSpc>
+                <a:spcPct val="100000"/>
+              </a:lnSpc>
               <a:buNone/>
+              <a:tabLst>
+                <a:tab algn="l" pos="0"/>
+              </a:tabLst>
             </a:pPr>
             <a:r>
               <a:rPr lang="en-GB" sz="1800" b="1" u="none" strike="noStrike">
@@ -1171,13 +1354,13 @@
               </a:rPr>
               <a:t>&lt;footer&gt;</a:t>
             </a:r>
-            <a:endParaRPr lang="en-GB" sz="1800" b="1" u="none" strike="noStrike">
-              <a:solidFill>
-                <a:srgbClr val="ffffff"/>
-              </a:solidFill>
-              <a:effectLst/>
-              <a:uFillTx/>
-              <a:latin typeface="Noto Sans"/>
+            <a:endParaRPr lang="en-GB" sz="1800" b="0" u="none" strike="noStrike">
+              <a:solidFill>
+                <a:srgbClr val="000000"/>
+              </a:solidFill>
+              <a:effectLst/>
+              <a:uFillTx/>
+              <a:latin typeface="Times New Roman"/>
             </a:endParaRPr>
           </a:p>
         </p:txBody>
@@ -1194,8 +1377,8 @@
         </p:nvSpPr>
         <p:spPr>
           <a:xfrm>
-            <a:off x="9180000" y="5130000"/>
-            <a:ext cx="720000" cy="540000"/>
+            <a:off x="9180000" y="5262480"/>
+            <a:ext cx="719640" cy="274680"/>
           </a:xfrm>
           <a:prstGeom prst="rect">
             <a:avLst/>
@@ -1211,7 +1394,13 @@
           </a:bodyPr>
           <a:lstStyle>
             <a:lvl1pPr indent="0" algn="ctr">
+              <a:lnSpc>
+                <a:spcPct val="100000"/>
+              </a:lnSpc>
               <a:buNone/>
+              <a:tabLst>
+                <a:tab algn="l" pos="0"/>
+              </a:tabLst>
               <a:defRPr lang="en-GB" sz="1800" b="1" u="none" strike="noStrike">
                 <a:solidFill>
                   <a:srgbClr val="ffffff"/>
@@ -1224,9 +1413,15 @@
           </a:lstStyle>
           <a:p>
             <a:pPr indent="0" algn="ctr">
+              <a:lnSpc>
+                <a:spcPct val="100000"/>
+              </a:lnSpc>
               <a:buNone/>
-            </a:pPr>
-            <a:fld id="{19D2BFDA-566A-40E3-8BB1-597613869AF5}" type="slidenum">
+              <a:tabLst>
+                <a:tab algn="l" pos="0"/>
+              </a:tabLst>
+            </a:pPr>
+            <a:fld id="{F8BBB361-2B3A-43F6-AE89-F061E6590BFF}" type="slidenum">
               <a:rPr lang="en-GB" sz="1800" b="1" u="none" strike="noStrike">
                 <a:solidFill>
                   <a:srgbClr val="ffffff"/>
@@ -1237,13 +1432,13 @@
               </a:rPr>
               <a:t>&lt;number&gt;</a:t>
             </a:fld>
-            <a:endParaRPr lang="en-GB" sz="1800" b="1" u="none" strike="noStrike">
-              <a:solidFill>
-                <a:srgbClr val="ffffff"/>
-              </a:solidFill>
-              <a:effectLst/>
-              <a:uFillTx/>
-              <a:latin typeface="Noto Sans"/>
+            <a:endParaRPr lang="en-GB" sz="1800" b="0" u="none" strike="noStrike">
+              <a:solidFill>
+                <a:srgbClr val="000000"/>
+              </a:solidFill>
+              <a:effectLst/>
+              <a:uFillTx/>
+              <a:latin typeface="Times New Roman"/>
             </a:endParaRPr>
           </a:p>
         </p:txBody>
@@ -1279,7 +1474,7 @@
         <p:spPr>
           <a:xfrm>
             <a:off x="0" y="0"/>
-            <a:ext cx="10080000" cy="5670000"/>
+            <a:ext cx="10079640" cy="5669640"/>
           </a:xfrm>
           <a:prstGeom prst="rect">
             <a:avLst/>
@@ -1302,6 +1497,11 @@
             <a:spAutoFit/>
           </a:bodyPr>
           <a:p>
+            <a:pPr>
+              <a:lnSpc>
+                <a:spcPct val="100000"/>
+              </a:lnSpc>
+            </a:pPr>
             <a:endParaRPr lang="en-GB" sz="1400" b="1" u="none" strike="noStrike">
               <a:solidFill>
                 <a:srgbClr val="ffffff"/>
@@ -1309,6 +1509,7 @@
               <a:effectLst/>
               <a:uFillTx/>
               <a:latin typeface="Noto Sans"/>
+              <a:ea typeface="DejaVu Sans"/>
             </a:endParaRPr>
           </a:p>
         </p:txBody>
@@ -1322,7 +1523,7 @@
         <p:spPr>
           <a:xfrm>
             <a:off x="2520000" y="1350000"/>
-            <a:ext cx="5040000" cy="1890000"/>
+            <a:ext cx="5039640" cy="1889640"/>
           </a:xfrm>
           <a:prstGeom prst="wedgeRectCallout">
             <a:avLst>
@@ -1351,6 +1552,11 @@
             <a:noAutofit/>
           </a:bodyPr>
           <a:p>
+            <a:pPr>
+              <a:lnSpc>
+                <a:spcPct val="100000"/>
+              </a:lnSpc>
+            </a:pPr>
             <a:endParaRPr lang="en-GB" sz="1400" b="1" u="none" strike="noStrike">
               <a:solidFill>
                 <a:srgbClr val="2c3e50"/>
@@ -1358,6 +1564,7 @@
               <a:effectLst/>
               <a:uFillTx/>
               <a:latin typeface="Noto Sans"/>
+              <a:ea typeface="DejaVu Sans"/>
             </a:endParaRPr>
           </a:p>
         </p:txBody>
@@ -1375,7 +1582,7 @@
         <p:spPr>
           <a:xfrm>
             <a:off x="2700000" y="1485000"/>
-            <a:ext cx="4680000" cy="1620000"/>
+            <a:ext cx="4679640" cy="1619640"/>
           </a:xfrm>
           <a:prstGeom prst="rect">
             <a:avLst/>
@@ -1391,7 +1598,13 @@
           </a:bodyPr>
           <a:p>
             <a:pPr indent="0" algn="ctr">
+              <a:lnSpc>
+                <a:spcPct val="100000"/>
+              </a:lnSpc>
               <a:buNone/>
+              <a:tabLst>
+                <a:tab algn="l" pos="0"/>
+              </a:tabLst>
             </a:pPr>
             <a:r>
               <a:rPr lang="en-GB" sz="2700" b="1" u="none" strike="noStrike">
@@ -1404,13 +1617,13 @@
               </a:rPr>
               <a:t>Click to edit the title text format</a:t>
             </a:r>
-            <a:endParaRPr lang="en-GB" sz="2700" b="1" u="none" strike="noStrike">
-              <a:solidFill>
-                <a:srgbClr val="2c3e50"/>
-              </a:solidFill>
-              <a:effectLst/>
-              <a:uFillTx/>
-              <a:latin typeface="Noto Sans"/>
+            <a:endParaRPr lang="en-GB" sz="2700" b="0" u="none" strike="noStrike">
+              <a:solidFill>
+                <a:srgbClr val="000000"/>
+              </a:solidFill>
+              <a:effectLst/>
+              <a:uFillTx/>
+              <a:latin typeface="Arial"/>
             </a:endParaRPr>
           </a:p>
         </p:txBody>
@@ -1428,7 +1641,7 @@
         <p:spPr>
           <a:xfrm>
             <a:off x="3420000" y="3240000"/>
-            <a:ext cx="6300000" cy="1620000"/>
+            <a:ext cx="6299640" cy="1619640"/>
           </a:xfrm>
           <a:prstGeom prst="rect">
             <a:avLst/>
@@ -1440,13 +1653,20 @@
         </p:spPr>
         <p:txBody>
           <a:bodyPr lIns="0" rIns="0" tIns="0" bIns="0" anchor="t">
-            <a:normAutofit fontScale="85000" lnSpcReduction="19999"/>
+            <a:normAutofit fontScale="85000" lnSpcReduction="9999"/>
           </a:bodyPr>
           <a:p>
             <a:pPr marL="432000" indent="0">
+              <a:lnSpc>
+                <a:spcPct val="100000"/>
+              </a:lnSpc>
               <a:spcAft>
                 <a:spcPts val="655"/>
               </a:spcAft>
+              <a:buNone/>
+              <a:tabLst>
+                <a:tab algn="l" pos="0"/>
+              </a:tabLst>
             </a:pPr>
             <a:r>
               <a:rPr lang="en-GB" sz="1500" b="0" u="none" strike="noStrike">
@@ -1461,18 +1681,25 @@
             </a:r>
             <a:endParaRPr lang="en-GB" sz="1500" b="0" u="none" strike="noStrike">
               <a:solidFill>
-                <a:srgbClr val="ffffff"/>
-              </a:solidFill>
-              <a:effectLst/>
-              <a:uFillTx/>
-              <a:latin typeface="Noto Sans"/>
-            </a:endParaRPr>
-          </a:p>
-          <a:p>
-            <a:pPr marL="864000" lvl="1" indent="0">
+                <a:srgbClr val="000000"/>
+              </a:solidFill>
+              <a:effectLst/>
+              <a:uFillTx/>
+              <a:latin typeface="Arial"/>
+            </a:endParaRPr>
+          </a:p>
+          <a:p>
+            <a:pPr marL="864000" indent="0">
+              <a:lnSpc>
+                <a:spcPct val="100000"/>
+              </a:lnSpc>
               <a:spcAft>
                 <a:spcPts val="850"/>
               </a:spcAft>
+              <a:buNone/>
+              <a:tabLst>
+                <a:tab algn="l" pos="0"/>
+              </a:tabLst>
             </a:pPr>
             <a:r>
               <a:rPr lang="en-GB" sz="1500" b="0" u="none" strike="noStrike">
@@ -1487,18 +1714,25 @@
             </a:r>
             <a:endParaRPr lang="en-GB" sz="1500" b="0" u="none" strike="noStrike">
               <a:solidFill>
-                <a:srgbClr val="ffffff"/>
-              </a:solidFill>
-              <a:effectLst/>
-              <a:uFillTx/>
-              <a:latin typeface="Noto Sans"/>
-            </a:endParaRPr>
-          </a:p>
-          <a:p>
-            <a:pPr marL="1296000" lvl="2" indent="0">
+                <a:srgbClr val="000000"/>
+              </a:solidFill>
+              <a:effectLst/>
+              <a:uFillTx/>
+              <a:latin typeface="Arial"/>
+            </a:endParaRPr>
+          </a:p>
+          <a:p>
+            <a:pPr marL="1296000" indent="0">
+              <a:lnSpc>
+                <a:spcPct val="100000"/>
+              </a:lnSpc>
               <a:spcAft>
                 <a:spcPts val="635"/>
               </a:spcAft>
+              <a:buNone/>
+              <a:tabLst>
+                <a:tab algn="l" pos="0"/>
+              </a:tabLst>
             </a:pPr>
             <a:r>
               <a:rPr lang="en-GB" sz="1500" b="0" u="none" strike="noStrike">
@@ -1513,18 +1747,25 @@
             </a:r>
             <a:endParaRPr lang="en-GB" sz="1500" b="0" u="none" strike="noStrike">
               <a:solidFill>
-                <a:srgbClr val="ffffff"/>
-              </a:solidFill>
-              <a:effectLst/>
-              <a:uFillTx/>
-              <a:latin typeface="Noto Sans"/>
-            </a:endParaRPr>
-          </a:p>
-          <a:p>
-            <a:pPr marL="1728000" lvl="3" indent="0">
+                <a:srgbClr val="000000"/>
+              </a:solidFill>
+              <a:effectLst/>
+              <a:uFillTx/>
+              <a:latin typeface="Arial"/>
+            </a:endParaRPr>
+          </a:p>
+          <a:p>
+            <a:pPr marL="1728000" indent="0">
+              <a:lnSpc>
+                <a:spcPct val="100000"/>
+              </a:lnSpc>
               <a:spcAft>
                 <a:spcPts val="425"/>
               </a:spcAft>
+              <a:buNone/>
+              <a:tabLst>
+                <a:tab algn="l" pos="0"/>
+              </a:tabLst>
             </a:pPr>
             <a:r>
               <a:rPr lang="en-GB" sz="1500" b="0" u="none" strike="noStrike">
@@ -1539,18 +1780,25 @@
             </a:r>
             <a:endParaRPr lang="en-GB" sz="1500" b="0" u="none" strike="noStrike">
               <a:solidFill>
-                <a:srgbClr val="ffffff"/>
-              </a:solidFill>
-              <a:effectLst/>
-              <a:uFillTx/>
-              <a:latin typeface="Noto Sans"/>
-            </a:endParaRPr>
-          </a:p>
-          <a:p>
-            <a:pPr marL="2160000" lvl="4" indent="0">
+                <a:srgbClr val="000000"/>
+              </a:solidFill>
+              <a:effectLst/>
+              <a:uFillTx/>
+              <a:latin typeface="Arial"/>
+            </a:endParaRPr>
+          </a:p>
+          <a:p>
+            <a:pPr marL="2160000" indent="0">
+              <a:lnSpc>
+                <a:spcPct val="100000"/>
+              </a:lnSpc>
               <a:spcAft>
                 <a:spcPts val="213"/>
               </a:spcAft>
+              <a:buNone/>
+              <a:tabLst>
+                <a:tab algn="l" pos="0"/>
+              </a:tabLst>
             </a:pPr>
             <a:r>
               <a:rPr lang="en-GB" sz="1500" b="0" u="none" strike="noStrike">
@@ -1565,18 +1813,25 @@
             </a:r>
             <a:endParaRPr lang="en-GB" sz="1500" b="0" u="none" strike="noStrike">
               <a:solidFill>
-                <a:srgbClr val="ffffff"/>
-              </a:solidFill>
-              <a:effectLst/>
-              <a:uFillTx/>
-              <a:latin typeface="Noto Sans"/>
-            </a:endParaRPr>
-          </a:p>
-          <a:p>
-            <a:pPr marL="2592000" lvl="5" indent="0">
+                <a:srgbClr val="000000"/>
+              </a:solidFill>
+              <a:effectLst/>
+              <a:uFillTx/>
+              <a:latin typeface="Arial"/>
+            </a:endParaRPr>
+          </a:p>
+          <a:p>
+            <a:pPr marL="2592000" indent="0">
+              <a:lnSpc>
+                <a:spcPct val="100000"/>
+              </a:lnSpc>
               <a:spcAft>
                 <a:spcPts val="213"/>
               </a:spcAft>
+              <a:buNone/>
+              <a:tabLst>
+                <a:tab algn="l" pos="0"/>
+              </a:tabLst>
             </a:pPr>
             <a:r>
               <a:rPr lang="en-GB" sz="1500" b="0" u="none" strike="noStrike">
@@ -1591,18 +1846,25 @@
             </a:r>
             <a:endParaRPr lang="en-GB" sz="1500" b="0" u="none" strike="noStrike">
               <a:solidFill>
-                <a:srgbClr val="ffffff"/>
-              </a:solidFill>
-              <a:effectLst/>
-              <a:uFillTx/>
-              <a:latin typeface="Noto Sans"/>
-            </a:endParaRPr>
-          </a:p>
-          <a:p>
-            <a:pPr marL="3024000" lvl="6" indent="0">
+                <a:srgbClr val="000000"/>
+              </a:solidFill>
+              <a:effectLst/>
+              <a:uFillTx/>
+              <a:latin typeface="Arial"/>
+            </a:endParaRPr>
+          </a:p>
+          <a:p>
+            <a:pPr marL="3024000" indent="0">
+              <a:lnSpc>
+                <a:spcPct val="100000"/>
+              </a:lnSpc>
               <a:spcAft>
                 <a:spcPts val="213"/>
               </a:spcAft>
+              <a:buNone/>
+              <a:tabLst>
+                <a:tab algn="l" pos="0"/>
+              </a:tabLst>
             </a:pPr>
             <a:r>
               <a:rPr lang="en-GB" sz="1500" b="0" u="none" strike="noStrike">
@@ -1617,11 +1879,11 @@
             </a:r>
             <a:endParaRPr lang="en-GB" sz="1500" b="0" u="none" strike="noStrike">
               <a:solidFill>
-                <a:srgbClr val="ffffff"/>
-              </a:solidFill>
-              <a:effectLst/>
-              <a:uFillTx/>
-              <a:latin typeface="Noto Sans"/>
+                <a:srgbClr val="000000"/>
+              </a:solidFill>
+              <a:effectLst/>
+              <a:uFillTx/>
+              <a:latin typeface="Arial"/>
             </a:endParaRPr>
           </a:p>
         </p:txBody>
@@ -1639,7 +1901,7 @@
         <p:spPr>
           <a:xfrm>
             <a:off x="360000" y="5400000"/>
-            <a:ext cx="2880000" cy="311400"/>
+            <a:ext cx="2879640" cy="311400"/>
           </a:xfrm>
           <a:prstGeom prst="rect">
             <a:avLst/>
@@ -1655,7 +1917,13 @@
           </a:bodyPr>
           <a:lstStyle>
             <a:lvl1pPr indent="0">
+              <a:lnSpc>
+                <a:spcPct val="100000"/>
+              </a:lnSpc>
               <a:buNone/>
+              <a:tabLst>
+                <a:tab algn="l" pos="0"/>
+              </a:tabLst>
               <a:defRPr lang="en-GB" sz="1800" b="1" u="none" strike="noStrike">
                 <a:solidFill>
                   <a:srgbClr val="ffffff"/>
@@ -1668,7 +1936,13 @@
           </a:lstStyle>
           <a:p>
             <a:pPr indent="0">
+              <a:lnSpc>
+                <a:spcPct val="100000"/>
+              </a:lnSpc>
               <a:buNone/>
+              <a:tabLst>
+                <a:tab algn="l" pos="0"/>
+              </a:tabLst>
             </a:pPr>
             <a:r>
               <a:rPr lang="en-GB" sz="1800" b="1" u="none" strike="noStrike">
@@ -1681,13 +1955,13 @@
               </a:rPr>
               <a:t>&lt;date/time&gt;</a:t>
             </a:r>
-            <a:endParaRPr lang="en-GB" sz="1800" b="1" u="none" strike="noStrike">
-              <a:solidFill>
-                <a:srgbClr val="ffffff"/>
-              </a:solidFill>
-              <a:effectLst/>
-              <a:uFillTx/>
-              <a:latin typeface="Noto Sans"/>
+            <a:endParaRPr lang="en-GB" sz="1800" b="0" u="none" strike="noStrike">
+              <a:solidFill>
+                <a:srgbClr val="000000"/>
+              </a:solidFill>
+              <a:effectLst/>
+              <a:uFillTx/>
+              <a:latin typeface="Times New Roman"/>
             </a:endParaRPr>
           </a:p>
         </p:txBody>
@@ -1705,7 +1979,7 @@
         <p:spPr>
           <a:xfrm>
             <a:off x="3420000" y="5400000"/>
-            <a:ext cx="3240000" cy="311400"/>
+            <a:ext cx="3239640" cy="311400"/>
           </a:xfrm>
           <a:prstGeom prst="rect">
             <a:avLst/>
@@ -1721,7 +1995,13 @@
           </a:bodyPr>
           <a:lstStyle>
             <a:lvl1pPr indent="0" algn="ctr">
+              <a:lnSpc>
+                <a:spcPct val="100000"/>
+              </a:lnSpc>
               <a:buNone/>
+              <a:tabLst>
+                <a:tab algn="l" pos="0"/>
+              </a:tabLst>
               <a:defRPr lang="en-GB" sz="1800" b="1" u="none" strike="noStrike">
                 <a:solidFill>
                   <a:srgbClr val="ffffff"/>
@@ -1734,7 +2014,13 @@
           </a:lstStyle>
           <a:p>
             <a:pPr indent="0" algn="ctr">
+              <a:lnSpc>
+                <a:spcPct val="100000"/>
+              </a:lnSpc>
               <a:buNone/>
+              <a:tabLst>
+                <a:tab algn="l" pos="0"/>
+              </a:tabLst>
             </a:pPr>
             <a:r>
               <a:rPr lang="en-GB" sz="1800" b="1" u="none" strike="noStrike">
@@ -1747,13 +2033,13 @@
               </a:rPr>
               <a:t>&lt;footer&gt;</a:t>
             </a:r>
-            <a:endParaRPr lang="en-GB" sz="1800" b="1" u="none" strike="noStrike">
-              <a:solidFill>
-                <a:srgbClr val="ffffff"/>
-              </a:solidFill>
-              <a:effectLst/>
-              <a:uFillTx/>
-              <a:latin typeface="Noto Sans"/>
+            <a:endParaRPr lang="en-GB" sz="1800" b="0" u="none" strike="noStrike">
+              <a:solidFill>
+                <a:srgbClr val="000000"/>
+              </a:solidFill>
+              <a:effectLst/>
+              <a:uFillTx/>
+              <a:latin typeface="Times New Roman"/>
             </a:endParaRPr>
           </a:p>
         </p:txBody>
@@ -1770,8 +2056,8 @@
         </p:nvSpPr>
         <p:spPr>
           <a:xfrm>
-            <a:off x="9180000" y="5130000"/>
-            <a:ext cx="720000" cy="540000"/>
+            <a:off x="9180000" y="5262480"/>
+            <a:ext cx="719640" cy="274680"/>
           </a:xfrm>
           <a:prstGeom prst="rect">
             <a:avLst/>
@@ -1787,7 +2073,13 @@
           </a:bodyPr>
           <a:lstStyle>
             <a:lvl1pPr indent="0" algn="ctr">
+              <a:lnSpc>
+                <a:spcPct val="100000"/>
+              </a:lnSpc>
               <a:buNone/>
+              <a:tabLst>
+                <a:tab algn="l" pos="0"/>
+              </a:tabLst>
               <a:defRPr lang="en-GB" sz="1800" b="1" u="none" strike="noStrike">
                 <a:solidFill>
                   <a:srgbClr val="ffffff"/>
@@ -1800,9 +2092,15 @@
           </a:lstStyle>
           <a:p>
             <a:pPr indent="0" algn="ctr">
+              <a:lnSpc>
+                <a:spcPct val="100000"/>
+              </a:lnSpc>
               <a:buNone/>
-            </a:pPr>
-            <a:fld id="{C8F0DD7C-04AA-45B7-85A8-2C51F3333B9F}" type="slidenum">
+              <a:tabLst>
+                <a:tab algn="l" pos="0"/>
+              </a:tabLst>
+            </a:pPr>
+            <a:fld id="{334437E0-B720-4DAF-B768-E2E640FA0523}" type="slidenum">
               <a:rPr lang="en-GB" sz="1800" b="1" u="none" strike="noStrike">
                 <a:solidFill>
                   <a:srgbClr val="ffffff"/>
@@ -1813,13 +2111,13 @@
               </a:rPr>
               <a:t>&lt;number&gt;</a:t>
             </a:fld>
-            <a:endParaRPr lang="en-GB" sz="1800" b="1" u="none" strike="noStrike">
-              <a:solidFill>
-                <a:srgbClr val="ffffff"/>
-              </a:solidFill>
-              <a:effectLst/>
-              <a:uFillTx/>
-              <a:latin typeface="Noto Sans"/>
+            <a:endParaRPr lang="en-GB" sz="1800" b="0" u="none" strike="noStrike">
+              <a:solidFill>
+                <a:srgbClr val="000000"/>
+              </a:solidFill>
+              <a:effectLst/>
+              <a:uFillTx/>
+              <a:latin typeface="Times New Roman"/>
             </a:endParaRPr>
           </a:p>
         </p:txBody>
@@ -1887,7 +2185,7 @@
         <p:spPr>
           <a:xfrm>
             <a:off x="360000" y="225720"/>
-            <a:ext cx="9360000" cy="720000"/>
+            <a:ext cx="9359640" cy="719640"/>
           </a:xfrm>
           <a:prstGeom prst="rect">
             <a:avLst/>
@@ -1903,7 +2201,13 @@
           </a:bodyPr>
           <a:p>
             <a:pPr indent="0" algn="ctr">
+              <a:lnSpc>
+                <a:spcPct val="100000"/>
+              </a:lnSpc>
               <a:buNone/>
+              <a:tabLst>
+                <a:tab algn="l" pos="0"/>
+              </a:tabLst>
             </a:pPr>
             <a:r>
               <a:rPr lang="en-GB" sz="3800" b="1" u="none" strike="noStrike">
@@ -1916,13 +2220,13 @@
               </a:rPr>
               <a:t>FINAL YEAR PROJECT PRESENTATION</a:t>
             </a:r>
-            <a:endParaRPr lang="en-GB" sz="3800" b="1" u="none" strike="noStrike">
-              <a:solidFill>
-                <a:srgbClr val="ffffff"/>
-              </a:solidFill>
-              <a:effectLst/>
-              <a:uFillTx/>
-              <a:latin typeface="Times New Roman"/>
+            <a:endParaRPr lang="en-GB" sz="3800" b="0" u="none" strike="noStrike">
+              <a:solidFill>
+                <a:srgbClr val="000000"/>
+              </a:solidFill>
+              <a:effectLst/>
+              <a:uFillTx/>
+              <a:latin typeface="Arial"/>
             </a:endParaRPr>
           </a:p>
         </p:txBody>
@@ -1940,7 +2244,7 @@
         <p:spPr>
           <a:xfrm>
             <a:off x="360000" y="1485000"/>
-            <a:ext cx="9360000" cy="3780000"/>
+            <a:ext cx="9359640" cy="3779640"/>
           </a:xfrm>
           <a:prstGeom prst="rect">
             <a:avLst/>
@@ -1963,6 +2267,9 @@
                 <a:spcPts val="1057"/>
               </a:spcAft>
               <a:buNone/>
+              <a:tabLst>
+                <a:tab algn="l" pos="0"/>
+              </a:tabLst>
             </a:pPr>
             <a:r>
               <a:rPr lang="en-GB" sz="2800" b="1" u="none" strike="noStrike">
@@ -1986,13 +2293,13 @@
               </a:rPr>
               <a:t>End of Semester 1</a:t>
             </a:r>
-            <a:endParaRPr lang="en-GB" sz="2800" b="1" u="none" strike="noStrike">
-              <a:solidFill>
-                <a:srgbClr val="2c3e50"/>
-              </a:solidFill>
-              <a:effectLst/>
-              <a:uFillTx/>
-              <a:latin typeface="Times New Roman"/>
+            <a:endParaRPr lang="en-GB" sz="2800" b="0" u="none" strike="noStrike">
+              <a:solidFill>
+                <a:srgbClr val="000000"/>
+              </a:solidFill>
+              <a:effectLst/>
+              <a:uFillTx/>
+              <a:latin typeface="Arial"/>
             </a:endParaRPr>
           </a:p>
           <a:p>
@@ -2004,6 +2311,9 @@
                 <a:spcPts val="1057"/>
               </a:spcAft>
               <a:buNone/>
+              <a:tabLst>
+                <a:tab algn="l" pos="0"/>
+              </a:tabLst>
             </a:pPr>
             <a:r>
               <a:rPr lang="en-GB" sz="2800" b="1" u="none" strike="noStrike">
@@ -2027,13 +2337,13 @@
               </a:rPr>
               <a:t>Musyani, Samuel Dan</a:t>
             </a:r>
-            <a:endParaRPr lang="en-GB" sz="2800" b="1" u="none" strike="noStrike">
-              <a:solidFill>
-                <a:srgbClr val="2c3e50"/>
-              </a:solidFill>
-              <a:effectLst/>
-              <a:uFillTx/>
-              <a:latin typeface="Times New Roman"/>
+            <a:endParaRPr lang="en-GB" sz="2800" b="0" u="none" strike="noStrike">
+              <a:solidFill>
+                <a:srgbClr val="000000"/>
+              </a:solidFill>
+              <a:effectLst/>
+              <a:uFillTx/>
+              <a:latin typeface="Arial"/>
             </a:endParaRPr>
           </a:p>
           <a:p>
@@ -2045,6 +2355,9 @@
                 <a:spcPts val="1057"/>
               </a:spcAft>
               <a:buNone/>
+              <a:tabLst>
+                <a:tab algn="l" pos="0"/>
+              </a:tabLst>
             </a:pPr>
             <a:r>
               <a:rPr lang="en-GB" sz="2800" b="1" u="none" strike="noStrike">
@@ -2068,13 +2381,13 @@
               </a:rPr>
               <a:t>Dr. Hashim Iddi</a:t>
             </a:r>
-            <a:endParaRPr lang="en-GB" sz="2800" b="1" u="none" strike="noStrike">
-              <a:solidFill>
-                <a:srgbClr val="2c3e50"/>
-              </a:solidFill>
-              <a:effectLst/>
-              <a:uFillTx/>
-              <a:latin typeface="Times New Roman"/>
+            <a:endParaRPr lang="en-GB" sz="2800" b="0" u="none" strike="noStrike">
+              <a:solidFill>
+                <a:srgbClr val="000000"/>
+              </a:solidFill>
+              <a:effectLst/>
+              <a:uFillTx/>
+              <a:latin typeface="Arial"/>
             </a:endParaRPr>
           </a:p>
           <a:p>
@@ -2086,6 +2399,9 @@
                 <a:spcPts val="1057"/>
               </a:spcAft>
               <a:buNone/>
+              <a:tabLst>
+                <a:tab algn="l" pos="0"/>
+              </a:tabLst>
             </a:pPr>
             <a:r>
               <a:rPr lang="en-GB" sz="2800" b="1" u="none" strike="noStrike">
@@ -2109,13 +2425,13 @@
               </a:rPr>
               <a:t>Design and Implementation of an Automated ID Card Issuance System</a:t>
             </a:r>
-            <a:endParaRPr lang="en-GB" sz="2800" b="1" u="none" strike="noStrike">
-              <a:solidFill>
-                <a:srgbClr val="2c3e50"/>
-              </a:solidFill>
-              <a:effectLst/>
-              <a:uFillTx/>
-              <a:latin typeface="Times New Roman"/>
+            <a:endParaRPr lang="en-GB" sz="2800" b="0" u="none" strike="noStrike">
+              <a:solidFill>
+                <a:srgbClr val="000000"/>
+              </a:solidFill>
+              <a:effectLst/>
+              <a:uFillTx/>
+              <a:latin typeface="Arial"/>
             </a:endParaRPr>
           </a:p>
         </p:txBody>
@@ -2134,7 +2450,7 @@
         <p:txBody>
           <a:bodyPr/>
           <a:p>
-            <a:fld id="{21BA709A-E03F-4DC3-A562-D119C8A09C9C}" type="slidenum">
+            <a:fld id="{70F8DDF2-FA8B-4AAB-8B76-ADEF5BDDFB88}" type="slidenum">
               <a:t>1</a:t>
             </a:fld>
           </a:p>
@@ -2183,7 +2499,7 @@
         <p:spPr>
           <a:xfrm>
             <a:off x="360000" y="225720"/>
-            <a:ext cx="9360000" cy="718920"/>
+            <a:ext cx="9359640" cy="718560"/>
           </a:xfrm>
           <a:prstGeom prst="rect">
             <a:avLst/>
@@ -2199,7 +2515,13 @@
           </a:bodyPr>
           <a:p>
             <a:pPr indent="0" algn="ctr">
+              <a:lnSpc>
+                <a:spcPct val="100000"/>
+              </a:lnSpc>
               <a:buNone/>
+              <a:tabLst>
+                <a:tab algn="l" pos="0"/>
+              </a:tabLst>
             </a:pPr>
             <a:r>
               <a:rPr lang="en-GB" sz="4000" b="1" u="none" strike="noStrike">
@@ -2212,13 +2534,13 @@
               </a:rPr>
               <a:t>CIRCUIT DESIGN AND SIMULATION</a:t>
             </a:r>
-            <a:endParaRPr lang="en-GB" sz="4000" b="1" u="none" strike="noStrike">
-              <a:solidFill>
-                <a:srgbClr val="ffffff"/>
-              </a:solidFill>
-              <a:effectLst/>
-              <a:uFillTx/>
-              <a:latin typeface="Noto Sans"/>
+            <a:endParaRPr lang="en-GB" sz="4000" b="0" u="none" strike="noStrike">
+              <a:solidFill>
+                <a:srgbClr val="000000"/>
+              </a:solidFill>
+              <a:effectLst/>
+              <a:uFillTx/>
+              <a:latin typeface="Arial"/>
             </a:endParaRPr>
           </a:p>
         </p:txBody>
@@ -2236,7 +2558,7 @@
         <p:spPr>
           <a:xfrm>
             <a:off x="360000" y="1485000"/>
-            <a:ext cx="9360000" cy="495000"/>
+            <a:ext cx="9359640" cy="494640"/>
           </a:xfrm>
           <a:prstGeom prst="rect">
             <a:avLst/>
@@ -2252,6 +2574,9 @@
           </a:bodyPr>
           <a:p>
             <a:pPr marL="432000" indent="-324000">
+              <a:lnSpc>
+                <a:spcPct val="100000"/>
+              </a:lnSpc>
               <a:spcAft>
                 <a:spcPts val="1057"/>
               </a:spcAft>
@@ -2263,23 +2588,23 @@
               <a:buChar char=""/>
             </a:pPr>
             <a:r>
-              <a:rPr lang="en-GB" sz="2400" b="1" u="none" strike="noStrike">
+              <a:rPr lang="en-GB" sz="2200" b="0" u="none" strike="noStrike">
                 <a:solidFill>
                   <a:srgbClr val="2c3e50"/>
                 </a:solidFill>
                 <a:effectLst/>
                 <a:uFillTx/>
-                <a:latin typeface="Noto Sans"/>
+                <a:latin typeface="Times New Roman"/>
               </a:rPr>
               <a:t>Power separation rail design</a:t>
             </a:r>
-            <a:endParaRPr lang="en-GB" sz="2400" b="1" u="none" strike="noStrike">
-              <a:solidFill>
-                <a:srgbClr val="2c3e50"/>
-              </a:solidFill>
-              <a:effectLst/>
-              <a:uFillTx/>
-              <a:latin typeface="Noto Sans"/>
+            <a:endParaRPr lang="en-GB" sz="2200" b="0" u="none" strike="noStrike">
+              <a:solidFill>
+                <a:srgbClr val="000000"/>
+              </a:solidFill>
+              <a:effectLst/>
+              <a:uFillTx/>
+              <a:latin typeface="Times New Roman"/>
             </a:endParaRPr>
           </a:p>
         </p:txBody>
@@ -2297,7 +2622,7 @@
         <p:spPr>
           <a:xfrm>
             <a:off x="339480" y="1980000"/>
-            <a:ext cx="5600520" cy="3005280"/>
+            <a:ext cx="5600160" cy="3004920"/>
           </a:xfrm>
           <a:prstGeom prst="rect">
             <a:avLst/>
@@ -2311,13 +2636,13 @@
       <p:sp>
         <p:nvSpPr>
           <p:cNvPr id="57" name=""/>
-          <p:cNvSpPr txBox="1"/>
+          <p:cNvSpPr/>
           <p:nvPr/>
         </p:nvSpPr>
         <p:spPr>
           <a:xfrm>
             <a:off x="6120000" y="1980000"/>
-            <a:ext cx="3780000" cy="2160000"/>
+            <a:ext cx="3779640" cy="2159640"/>
           </a:xfrm>
           <a:prstGeom prst="rect">
             <a:avLst/>
@@ -2327,9 +2652,15 @@
             <a:noFill/>
           </a:ln>
         </p:spPr>
+        <p:style>
+          <a:lnRef idx="0"/>
+          <a:fillRef idx="0"/>
+          <a:effectRef idx="0"/>
+          <a:fontRef idx="minor"/>
+        </p:style>
         <p:txBody>
           <a:bodyPr lIns="0" rIns="0" tIns="0" bIns="0" anchor="t">
-            <a:normAutofit/>
+            <a:normAutofit lnSpcReduction="9999"/>
           </a:bodyPr>
           <a:p>
             <a:pPr marL="432000" indent="-324000">
@@ -2347,7 +2678,7 @@
               <a:buChar char=""/>
             </a:pPr>
             <a:r>
-              <a:rPr lang="en-GB" sz="2400" b="1" u="none" strike="noStrike">
+              <a:rPr lang="en-GB" sz="2400" b="0" u="none" strike="noStrike">
                 <a:solidFill>
                   <a:srgbClr val="2c3e50"/>
                 </a:solidFill>
@@ -2357,13 +2688,13 @@
               </a:rPr>
               <a:t>Separation is done to prevent inrush current (motors) interfering from logic components</a:t>
             </a:r>
-            <a:endParaRPr lang="en-GB" sz="2400" b="1" u="none" strike="noStrike">
-              <a:solidFill>
-                <a:srgbClr val="2c3e50"/>
-              </a:solidFill>
-              <a:effectLst/>
-              <a:uFillTx/>
-              <a:latin typeface="Times New Roman"/>
+            <a:endParaRPr lang="en-GB" sz="2400" b="0" u="none" strike="noStrike">
+              <a:solidFill>
+                <a:srgbClr val="000000"/>
+              </a:solidFill>
+              <a:effectLst/>
+              <a:uFillTx/>
+              <a:latin typeface="Arial"/>
             </a:endParaRPr>
           </a:p>
         </p:txBody>
@@ -2382,7 +2713,7 @@
         <p:txBody>
           <a:bodyPr/>
           <a:p>
-            <a:fld id="{845A2241-29EE-4D18-8C0A-994DB7E06EE9}" type="slidenum">
+            <a:fld id="{8937386F-DA06-44A5-A2CB-1ED2E569FDB0}" type="slidenum">
               <a:t>10</a:t>
             </a:fld>
           </a:p>
@@ -2431,7 +2762,7 @@
         <p:spPr>
           <a:xfrm>
             <a:off x="360000" y="225720"/>
-            <a:ext cx="9360000" cy="718920"/>
+            <a:ext cx="9359640" cy="718560"/>
           </a:xfrm>
           <a:prstGeom prst="rect">
             <a:avLst/>
@@ -2447,7 +2778,13 @@
           </a:bodyPr>
           <a:p>
             <a:pPr indent="0" algn="ctr">
+              <a:lnSpc>
+                <a:spcPct val="100000"/>
+              </a:lnSpc>
               <a:buNone/>
+              <a:tabLst>
+                <a:tab algn="l" pos="0"/>
+              </a:tabLst>
             </a:pPr>
             <a:r>
               <a:rPr lang="en-GB" sz="4000" b="1" u="none" strike="noStrike">
@@ -2460,13 +2797,13 @@
               </a:rPr>
               <a:t>CIRCUIT DESIGN AND SIMULATION</a:t>
             </a:r>
-            <a:endParaRPr lang="en-GB" sz="4000" b="1" u="none" strike="noStrike">
-              <a:solidFill>
-                <a:srgbClr val="ffffff"/>
-              </a:solidFill>
-              <a:effectLst/>
-              <a:uFillTx/>
-              <a:latin typeface="Times New Roman"/>
+            <a:endParaRPr lang="en-GB" sz="4000" b="0" u="none" strike="noStrike">
+              <a:solidFill>
+                <a:srgbClr val="000000"/>
+              </a:solidFill>
+              <a:effectLst/>
+              <a:uFillTx/>
+              <a:latin typeface="Arial"/>
             </a:endParaRPr>
           </a:p>
         </p:txBody>
@@ -2484,7 +2821,7 @@
         <p:spPr>
           <a:xfrm>
             <a:off x="360000" y="1305000"/>
-            <a:ext cx="9360000" cy="495000"/>
+            <a:ext cx="9359640" cy="494640"/>
           </a:xfrm>
           <a:prstGeom prst="rect">
             <a:avLst/>
@@ -2500,6 +2837,9 @@
           </a:bodyPr>
           <a:p>
             <a:pPr marL="432000" indent="-324000">
+              <a:lnSpc>
+                <a:spcPct val="100000"/>
+              </a:lnSpc>
               <a:spcAft>
                 <a:spcPts val="1057"/>
               </a:spcAft>
@@ -2511,7 +2851,7 @@
               <a:buChar char=""/>
             </a:pPr>
             <a:r>
-              <a:rPr lang="en-GB" sz="2200" b="1" u="none" strike="noStrike">
+              <a:rPr lang="en-GB" sz="2200" b="0" u="none" strike="noStrike">
                 <a:solidFill>
                   <a:srgbClr val="2c3e50"/>
                 </a:solidFill>
@@ -2521,13 +2861,13 @@
               </a:rPr>
               <a:t>Reverse Polarity Protection Circuit</a:t>
             </a:r>
-            <a:endParaRPr lang="en-GB" sz="2200" b="1" u="none" strike="noStrike">
-              <a:solidFill>
-                <a:srgbClr val="2c3e50"/>
-              </a:solidFill>
-              <a:effectLst/>
-              <a:uFillTx/>
-              <a:latin typeface="Times New Roman"/>
+            <a:endParaRPr lang="en-GB" sz="2200" b="0" u="none" strike="noStrike">
+              <a:solidFill>
+                <a:srgbClr val="000000"/>
+              </a:solidFill>
+              <a:effectLst/>
+              <a:uFillTx/>
+              <a:latin typeface="Arial"/>
             </a:endParaRPr>
           </a:p>
         </p:txBody>
@@ -2546,7 +2886,7 @@
         <p:spPr>
           <a:xfrm>
             <a:off x="360360" y="1800360"/>
-            <a:ext cx="5399640" cy="1619640"/>
+            <a:ext cx="5399280" cy="1619280"/>
           </a:xfrm>
           <a:prstGeom prst="rect">
             <a:avLst/>
@@ -2560,13 +2900,13 @@
       <p:sp>
         <p:nvSpPr>
           <p:cNvPr id="61" name=""/>
-          <p:cNvSpPr txBox="1"/>
+          <p:cNvSpPr/>
           <p:nvPr/>
         </p:nvSpPr>
         <p:spPr>
           <a:xfrm>
             <a:off x="5760000" y="1800000"/>
-            <a:ext cx="4140000" cy="3420000"/>
+            <a:ext cx="4139640" cy="3419640"/>
           </a:xfrm>
           <a:prstGeom prst="rect">
             <a:avLst/>
@@ -2576,6 +2916,12 @@
             <a:noFill/>
           </a:ln>
         </p:spPr>
+        <p:style>
+          <a:lnRef idx="0"/>
+          <a:fillRef idx="0"/>
+          <a:effectRef idx="0"/>
+          <a:fontRef idx="minor"/>
+        </p:style>
         <p:txBody>
           <a:bodyPr lIns="0" rIns="0" tIns="0" bIns="0" anchor="t">
             <a:normAutofit/>
@@ -2596,7 +2942,7 @@
               <a:buChar char=""/>
             </a:pPr>
             <a:r>
-              <a:rPr lang="en-GB" sz="2200" b="1" u="none" strike="noStrike">
+              <a:rPr lang="en-GB" sz="2200" b="0" u="none" strike="noStrike">
                 <a:solidFill>
                   <a:srgbClr val="2c3e50"/>
                 </a:solidFill>
@@ -2606,13 +2952,13 @@
               </a:rPr>
               <a:t>Correct polarity connection allows connection to the output node</a:t>
             </a:r>
-            <a:endParaRPr lang="en-GB" sz="2200" b="1" u="none" strike="noStrike">
-              <a:solidFill>
-                <a:srgbClr val="2c3e50"/>
-              </a:solidFill>
-              <a:effectLst/>
-              <a:uFillTx/>
-              <a:latin typeface="Times New Roman"/>
+            <a:endParaRPr lang="en-GB" sz="2200" b="0" u="none" strike="noStrike">
+              <a:solidFill>
+                <a:srgbClr val="000000"/>
+              </a:solidFill>
+              <a:effectLst/>
+              <a:uFillTx/>
+              <a:latin typeface="Arial"/>
             </a:endParaRPr>
           </a:p>
           <a:p>
@@ -2631,7 +2977,7 @@
               <a:buChar char=""/>
             </a:pPr>
             <a:r>
-              <a:rPr lang="en-GB" sz="2200" b="1" u="none" strike="noStrike">
+              <a:rPr lang="en-GB" sz="2200" b="0" u="none" strike="noStrike">
                 <a:solidFill>
                   <a:srgbClr val="2c3e50"/>
                 </a:solidFill>
@@ -2641,13 +2987,13 @@
               </a:rPr>
               <a:t>Wrong polarity connection does not allow connection to the output node</a:t>
             </a:r>
-            <a:endParaRPr lang="en-GB" sz="2200" b="1" u="none" strike="noStrike">
-              <a:solidFill>
-                <a:srgbClr val="2c3e50"/>
-              </a:solidFill>
-              <a:effectLst/>
-              <a:uFillTx/>
-              <a:latin typeface="Times New Roman"/>
+            <a:endParaRPr lang="en-GB" sz="2200" b="0" u="none" strike="noStrike">
+              <a:solidFill>
+                <a:srgbClr val="000000"/>
+              </a:solidFill>
+              <a:effectLst/>
+              <a:uFillTx/>
+              <a:latin typeface="Arial"/>
             </a:endParaRPr>
           </a:p>
         </p:txBody>
@@ -2666,7 +3012,7 @@
         <p:spPr>
           <a:xfrm>
             <a:off x="360360" y="3600000"/>
-            <a:ext cx="5399640" cy="1692000"/>
+            <a:ext cx="5399280" cy="1691640"/>
           </a:xfrm>
           <a:prstGeom prst="rect">
             <a:avLst/>
@@ -2691,7 +3037,7 @@
         <p:txBody>
           <a:bodyPr/>
           <a:p>
-            <a:fld id="{B2902EEF-4997-4142-B979-70324F762298}" type="slidenum">
+            <a:fld id="{EAF54884-DB2B-4E63-84B0-57F34D476EEB}" type="slidenum">
               <a:t>11</a:t>
             </a:fld>
           </a:p>
@@ -2740,7 +3086,7 @@
         <p:spPr>
           <a:xfrm>
             <a:off x="360000" y="225720"/>
-            <a:ext cx="9360000" cy="718920"/>
+            <a:ext cx="9359640" cy="718560"/>
           </a:xfrm>
           <a:prstGeom prst="rect">
             <a:avLst/>
@@ -2756,7 +3102,13 @@
           </a:bodyPr>
           <a:p>
             <a:pPr indent="0" algn="ctr">
+              <a:lnSpc>
+                <a:spcPct val="100000"/>
+              </a:lnSpc>
               <a:buNone/>
+              <a:tabLst>
+                <a:tab algn="l" pos="0"/>
+              </a:tabLst>
             </a:pPr>
             <a:r>
               <a:rPr lang="en-GB" sz="4000" b="1" u="none" strike="noStrike">
@@ -2769,13 +3121,13 @@
               </a:rPr>
               <a:t>CIRCUIT DESIGN AND SIMULATION</a:t>
             </a:r>
-            <a:endParaRPr lang="en-GB" sz="4000" b="1" u="none" strike="noStrike">
-              <a:solidFill>
-                <a:srgbClr val="ffffff"/>
-              </a:solidFill>
-              <a:effectLst/>
-              <a:uFillTx/>
-              <a:latin typeface="Noto Sans"/>
+            <a:endParaRPr lang="en-GB" sz="4000" b="0" u="none" strike="noStrike">
+              <a:solidFill>
+                <a:srgbClr val="000000"/>
+              </a:solidFill>
+              <a:effectLst/>
+              <a:uFillTx/>
+              <a:latin typeface="Arial"/>
             </a:endParaRPr>
           </a:p>
         </p:txBody>
@@ -2793,7 +3145,7 @@
         <p:spPr>
           <a:xfrm>
             <a:off x="360000" y="1305000"/>
-            <a:ext cx="9360000" cy="495000"/>
+            <a:ext cx="9359640" cy="494640"/>
           </a:xfrm>
           <a:prstGeom prst="rect">
             <a:avLst/>
@@ -2809,6 +3161,9 @@
           </a:bodyPr>
           <a:p>
             <a:pPr marL="432000" indent="-324000">
+              <a:lnSpc>
+                <a:spcPct val="100000"/>
+              </a:lnSpc>
               <a:spcAft>
                 <a:spcPts val="1057"/>
               </a:spcAft>
@@ -2820,23 +3175,23 @@
               <a:buChar char=""/>
             </a:pPr>
             <a:r>
-              <a:rPr lang="en-GB" sz="2400" b="1" u="none" strike="noStrike">
+              <a:rPr lang="en-GB" sz="2200" b="0" u="none" strike="noStrike">
                 <a:solidFill>
                   <a:srgbClr val="2c3e50"/>
                 </a:solidFill>
                 <a:effectLst/>
                 <a:uFillTx/>
-                <a:latin typeface="Noto Sans"/>
+                <a:latin typeface="Times New Roman"/>
               </a:rPr>
               <a:t>Motor driver circuit</a:t>
             </a:r>
-            <a:endParaRPr lang="en-GB" sz="2400" b="1" u="none" strike="noStrike">
-              <a:solidFill>
-                <a:srgbClr val="2c3e50"/>
-              </a:solidFill>
-              <a:effectLst/>
-              <a:uFillTx/>
-              <a:latin typeface="Noto Sans"/>
+            <a:endParaRPr lang="en-GB" sz="2200" b="0" u="none" strike="noStrike">
+              <a:solidFill>
+                <a:srgbClr val="000000"/>
+              </a:solidFill>
+              <a:effectLst/>
+              <a:uFillTx/>
+              <a:latin typeface="Times New Roman"/>
             </a:endParaRPr>
           </a:p>
         </p:txBody>
@@ -2854,7 +3209,7 @@
         <p:spPr>
           <a:xfrm>
             <a:off x="469800" y="1920240"/>
-            <a:ext cx="5470200" cy="2939760"/>
+            <a:ext cx="5469840" cy="2939400"/>
           </a:xfrm>
           <a:prstGeom prst="rect">
             <a:avLst/>
@@ -2868,13 +3223,13 @@
       <p:sp>
         <p:nvSpPr>
           <p:cNvPr id="66" name=""/>
-          <p:cNvSpPr txBox="1"/>
+          <p:cNvSpPr/>
           <p:nvPr/>
         </p:nvSpPr>
         <p:spPr>
           <a:xfrm>
             <a:off x="6120000" y="1980000"/>
-            <a:ext cx="3780000" cy="1980000"/>
+            <a:ext cx="3779640" cy="1979640"/>
           </a:xfrm>
           <a:prstGeom prst="rect">
             <a:avLst/>
@@ -2884,9 +3239,15 @@
             <a:noFill/>
           </a:ln>
         </p:spPr>
+        <p:style>
+          <a:lnRef idx="0"/>
+          <a:fillRef idx="0"/>
+          <a:effectRef idx="0"/>
+          <a:fontRef idx="minor"/>
+        </p:style>
         <p:txBody>
           <a:bodyPr lIns="0" rIns="0" tIns="0" bIns="0" anchor="t">
-            <a:normAutofit/>
+            <a:normAutofit lnSpcReduction="9999"/>
           </a:bodyPr>
           <a:p>
             <a:pPr marL="432000" indent="-324000">
@@ -2904,7 +3265,7 @@
               <a:buChar char=""/>
             </a:pPr>
             <a:r>
-              <a:rPr lang="en-GB" sz="2200" b="1" u="none" strike="noStrike">
+              <a:rPr lang="en-GB" sz="2200" b="0" u="none" strike="noStrike">
                 <a:solidFill>
                   <a:srgbClr val="2c3e50"/>
                 </a:solidFill>
@@ -2914,13 +3275,13 @@
               </a:rPr>
               <a:t>ULN2003A driver circuit was designed to drive stepper motors and simulation went as expected</a:t>
             </a:r>
-            <a:endParaRPr lang="en-GB" sz="2200" b="1" u="none" strike="noStrike">
-              <a:solidFill>
-                <a:srgbClr val="2c3e50"/>
-              </a:solidFill>
-              <a:effectLst/>
-              <a:uFillTx/>
-              <a:latin typeface="Times New Roman"/>
+            <a:endParaRPr lang="en-GB" sz="2200" b="0" u="none" strike="noStrike">
+              <a:solidFill>
+                <a:srgbClr val="000000"/>
+              </a:solidFill>
+              <a:effectLst/>
+              <a:uFillTx/>
+              <a:latin typeface="Arial"/>
             </a:endParaRPr>
           </a:p>
         </p:txBody>
@@ -2939,7 +3300,7 @@
         <p:txBody>
           <a:bodyPr/>
           <a:p>
-            <a:fld id="{5DBA5274-88D8-46EF-A276-EDA6B576CBF3}" type="slidenum">
+            <a:fld id="{9A51F20F-6E62-4FB5-A021-483C25654E7B}" type="slidenum">
               <a:t>12</a:t>
             </a:fld>
           </a:p>
@@ -2988,7 +3349,7 @@
         <p:spPr>
           <a:xfrm>
             <a:off x="360000" y="225720"/>
-            <a:ext cx="9360000" cy="718920"/>
+            <a:ext cx="9359640" cy="718560"/>
           </a:xfrm>
           <a:prstGeom prst="rect">
             <a:avLst/>
@@ -3004,7 +3365,13 @@
           </a:bodyPr>
           <a:p>
             <a:pPr indent="0" algn="ctr">
+              <a:lnSpc>
+                <a:spcPct val="100000"/>
+              </a:lnSpc>
               <a:buNone/>
+              <a:tabLst>
+                <a:tab algn="l" pos="0"/>
+              </a:tabLst>
             </a:pPr>
             <a:r>
               <a:rPr lang="en-GB" sz="5400" b="1" u="none" strike="noStrike">
@@ -3017,13 +3384,13 @@
               </a:rPr>
               <a:t>CONCLUSION</a:t>
             </a:r>
-            <a:endParaRPr lang="en-GB" sz="5400" b="1" u="none" strike="noStrike">
-              <a:solidFill>
-                <a:srgbClr val="ffffff"/>
-              </a:solidFill>
-              <a:effectLst/>
-              <a:uFillTx/>
-              <a:latin typeface="Times New Roman"/>
+            <a:endParaRPr lang="en-GB" sz="5400" b="0" u="none" strike="noStrike">
+              <a:solidFill>
+                <a:srgbClr val="000000"/>
+              </a:solidFill>
+              <a:effectLst/>
+              <a:uFillTx/>
+              <a:latin typeface="Arial"/>
             </a:endParaRPr>
           </a:p>
         </p:txBody>
@@ -3041,7 +3408,7 @@
         <p:spPr>
           <a:xfrm>
             <a:off x="360000" y="1485000"/>
-            <a:ext cx="9360000" cy="3780000"/>
+            <a:ext cx="9359640" cy="3779640"/>
           </a:xfrm>
           <a:prstGeom prst="rect">
             <a:avLst/>
@@ -3071,7 +3438,7 @@
               <a:buChar char=""/>
             </a:pPr>
             <a:r>
-              <a:rPr lang="en-GB" sz="2400" b="1" u="none" strike="noStrike">
+              <a:rPr lang="en-GB" sz="2400" b="0" u="none" strike="noStrike">
                 <a:solidFill>
                   <a:srgbClr val="2c3e50"/>
                 </a:solidFill>
@@ -3081,13 +3448,13 @@
               </a:rPr>
               <a:t>Work done to date; system architecture design, computer vision pipeline, database creation, schematic design and electronic components’ simulation</a:t>
             </a:r>
-            <a:endParaRPr lang="en-GB" sz="2400" b="1" u="none" strike="noStrike">
-              <a:solidFill>
-                <a:srgbClr val="2c3e50"/>
-              </a:solidFill>
-              <a:effectLst/>
-              <a:uFillTx/>
-              <a:latin typeface="Times New Roman"/>
+            <a:endParaRPr lang="en-GB" sz="2400" b="0" u="none" strike="noStrike">
+              <a:solidFill>
+                <a:srgbClr val="000000"/>
+              </a:solidFill>
+              <a:effectLst/>
+              <a:uFillTx/>
+              <a:latin typeface="Arial"/>
             </a:endParaRPr>
           </a:p>
           <a:p>
@@ -3106,7 +3473,7 @@
               <a:buChar char=""/>
             </a:pPr>
             <a:r>
-              <a:rPr lang="en-GB" sz="2400" b="1" u="none" strike="noStrike">
+              <a:rPr lang="en-GB" sz="2400" b="0" u="none" strike="noStrike">
                 <a:solidFill>
                   <a:srgbClr val="2c3e50"/>
                 </a:solidFill>
@@ -3116,13 +3483,13 @@
               </a:rPr>
               <a:t>Next progress; authentication system, hardware components procurement, circuit integration and enclosure design and implementation </a:t>
             </a:r>
-            <a:endParaRPr lang="en-GB" sz="2400" b="1" u="none" strike="noStrike">
-              <a:solidFill>
-                <a:srgbClr val="2c3e50"/>
-              </a:solidFill>
-              <a:effectLst/>
-              <a:uFillTx/>
-              <a:latin typeface="Times New Roman"/>
+            <a:endParaRPr lang="en-GB" sz="2400" b="0" u="none" strike="noStrike">
+              <a:solidFill>
+                <a:srgbClr val="000000"/>
+              </a:solidFill>
+              <a:effectLst/>
+              <a:uFillTx/>
+              <a:latin typeface="Arial"/>
             </a:endParaRPr>
           </a:p>
         </p:txBody>
@@ -3141,7 +3508,7 @@
         <p:txBody>
           <a:bodyPr/>
           <a:p>
-            <a:fld id="{25DF06C3-00CB-45D9-8D26-69B960D17B82}" type="slidenum">
+            <a:fld id="{0252A40F-3874-4218-A9D8-21B68433E916}" type="slidenum">
               <a:t>13</a:t>
             </a:fld>
           </a:p>
@@ -3190,7 +3557,7 @@
         <p:spPr>
           <a:xfrm>
             <a:off x="360000" y="225720"/>
-            <a:ext cx="9360000" cy="718920"/>
+            <a:ext cx="9359640" cy="718560"/>
           </a:xfrm>
           <a:prstGeom prst="rect">
             <a:avLst/>
@@ -3206,7 +3573,13 @@
           </a:bodyPr>
           <a:p>
             <a:pPr indent="0" algn="ctr">
+              <a:lnSpc>
+                <a:spcPct val="100000"/>
+              </a:lnSpc>
               <a:buNone/>
+              <a:tabLst>
+                <a:tab algn="l" pos="0"/>
+              </a:tabLst>
             </a:pPr>
             <a:r>
               <a:rPr lang="en-GB" sz="5400" b="1" u="none" strike="noStrike">
@@ -3219,13 +3592,13 @@
               </a:rPr>
               <a:t>INTRODUCTION</a:t>
             </a:r>
-            <a:endParaRPr lang="en-GB" sz="5400" b="1" u="none" strike="noStrike">
-              <a:solidFill>
-                <a:srgbClr val="ffffff"/>
-              </a:solidFill>
-              <a:effectLst/>
-              <a:uFillTx/>
-              <a:latin typeface="Times New Roman"/>
+            <a:endParaRPr lang="en-GB" sz="5400" b="0" u="none" strike="noStrike">
+              <a:solidFill>
+                <a:srgbClr val="000000"/>
+              </a:solidFill>
+              <a:effectLst/>
+              <a:uFillTx/>
+              <a:latin typeface="Arial"/>
             </a:endParaRPr>
           </a:p>
         </p:txBody>
@@ -3243,7 +3616,7 @@
         <p:spPr>
           <a:xfrm>
             <a:off x="360000" y="1485000"/>
-            <a:ext cx="9360000" cy="3780000"/>
+            <a:ext cx="9359640" cy="3779640"/>
           </a:xfrm>
           <a:prstGeom prst="rect">
             <a:avLst/>
@@ -3255,7 +3628,7 @@
         </p:spPr>
         <p:txBody>
           <a:bodyPr lIns="0" rIns="0" tIns="0" bIns="0" anchor="t">
-            <a:normAutofit/>
+            <a:normAutofit lnSpcReduction="9999"/>
           </a:bodyPr>
           <a:p>
             <a:pPr marL="432000" indent="-324000" algn="just">
@@ -3273,7 +3646,7 @@
               <a:buChar char=""/>
             </a:pPr>
             <a:r>
-              <a:rPr lang="en-GB" sz="2800" b="1" u="none" strike="noStrike">
+              <a:rPr lang="en-GB" sz="2800" b="0" u="none" strike="noStrike">
                 <a:solidFill>
                   <a:srgbClr val="2c3e50"/>
                 </a:solidFill>
@@ -3283,13 +3656,13 @@
               </a:rPr>
               <a:t>The project aims to ease ID card issuance process for registered students by developing a prototype of an automated system.</a:t>
             </a:r>
-            <a:endParaRPr lang="en-GB" sz="2800" b="1" u="none" strike="noStrike">
-              <a:solidFill>
-                <a:srgbClr val="2c3e50"/>
-              </a:solidFill>
-              <a:effectLst/>
-              <a:uFillTx/>
-              <a:latin typeface="Times New Roman"/>
+            <a:endParaRPr lang="en-GB" sz="2800" b="0" u="none" strike="noStrike">
+              <a:solidFill>
+                <a:srgbClr val="000000"/>
+              </a:solidFill>
+              <a:effectLst/>
+              <a:uFillTx/>
+              <a:latin typeface="Arial"/>
             </a:endParaRPr>
           </a:p>
           <a:p>
@@ -3308,7 +3681,7 @@
               <a:buChar char=""/>
             </a:pPr>
             <a:r>
-              <a:rPr lang="en-GB" sz="2800" b="1" u="none" strike="noStrike">
+              <a:rPr lang="en-GB" sz="2800" b="0" u="none" strike="noStrike">
                 <a:solidFill>
                   <a:srgbClr val="2c3e50"/>
                 </a:solidFill>
@@ -3318,13 +3691,13 @@
               </a:rPr>
               <a:t>Registered students will be able to return their expired cards, and retrieve their valid ID cards  for that particular academic year.</a:t>
             </a:r>
-            <a:endParaRPr lang="en-GB" sz="2800" b="1" u="none" strike="noStrike">
-              <a:solidFill>
-                <a:srgbClr val="2c3e50"/>
-              </a:solidFill>
-              <a:effectLst/>
-              <a:uFillTx/>
-              <a:latin typeface="Times New Roman"/>
+            <a:endParaRPr lang="en-GB" sz="2800" b="0" u="none" strike="noStrike">
+              <a:solidFill>
+                <a:srgbClr val="000000"/>
+              </a:solidFill>
+              <a:effectLst/>
+              <a:uFillTx/>
+              <a:latin typeface="Arial"/>
             </a:endParaRPr>
           </a:p>
         </p:txBody>
@@ -3343,7 +3716,7 @@
         <p:txBody>
           <a:bodyPr/>
           <a:p>
-            <a:fld id="{F8B77DCF-D799-4693-9211-2E58140C4F87}" type="slidenum">
+            <a:fld id="{DFF18C57-5D88-4877-B86F-24AE11E4A531}" type="slidenum">
               <a:t>2</a:t>
             </a:fld>
           </a:p>
@@ -3392,7 +3765,7 @@
         <p:spPr>
           <a:xfrm>
             <a:off x="360000" y="225720"/>
-            <a:ext cx="9360000" cy="718920"/>
+            <a:ext cx="9359640" cy="718560"/>
           </a:xfrm>
           <a:prstGeom prst="rect">
             <a:avLst/>
@@ -3408,7 +3781,13 @@
           </a:bodyPr>
           <a:p>
             <a:pPr indent="0" algn="ctr">
+              <a:lnSpc>
+                <a:spcPct val="100000"/>
+              </a:lnSpc>
               <a:buNone/>
+              <a:tabLst>
+                <a:tab algn="l" pos="0"/>
+              </a:tabLst>
             </a:pPr>
             <a:r>
               <a:rPr lang="en-GB" sz="5400" b="1" u="none" strike="noStrike">
@@ -3421,13 +3800,13 @@
               </a:rPr>
               <a:t>PROBLEM STATEMENT</a:t>
             </a:r>
-            <a:endParaRPr lang="en-GB" sz="5400" b="1" u="none" strike="noStrike">
-              <a:solidFill>
-                <a:srgbClr val="ffffff"/>
-              </a:solidFill>
-              <a:effectLst/>
-              <a:uFillTx/>
-              <a:latin typeface="Times New Roman"/>
+            <a:endParaRPr lang="en-GB" sz="5400" b="0" u="none" strike="noStrike">
+              <a:solidFill>
+                <a:srgbClr val="000000"/>
+              </a:solidFill>
+              <a:effectLst/>
+              <a:uFillTx/>
+              <a:latin typeface="Arial"/>
             </a:endParaRPr>
           </a:p>
         </p:txBody>
@@ -3445,7 +3824,7 @@
         <p:spPr>
           <a:xfrm>
             <a:off x="360000" y="4140000"/>
-            <a:ext cx="9360000" cy="1125000"/>
+            <a:ext cx="9359640" cy="1124640"/>
           </a:xfrm>
           <a:prstGeom prst="rect">
             <a:avLst/>
@@ -3475,7 +3854,7 @@
               <a:buChar char=""/>
             </a:pPr>
             <a:r>
-              <a:rPr lang="en-GB" sz="2400" b="1" u="none" strike="noStrike">
+              <a:rPr lang="en-GB" sz="2400" b="0" u="none" strike="noStrike">
                 <a:solidFill>
                   <a:srgbClr val="2c3e50"/>
                 </a:solidFill>
@@ -3485,13 +3864,13 @@
               </a:rPr>
               <a:t>With high student volumes, narrow administrative working window leads to long queues and delayed distribution.</a:t>
             </a:r>
-            <a:endParaRPr lang="en-GB" sz="2400" b="1" u="none" strike="noStrike">
-              <a:solidFill>
-                <a:srgbClr val="2c3e50"/>
-              </a:solidFill>
-              <a:effectLst/>
-              <a:uFillTx/>
-              <a:latin typeface="Times New Roman"/>
+            <a:endParaRPr lang="en-GB" sz="2400" b="0" u="none" strike="noStrike">
+              <a:solidFill>
+                <a:srgbClr val="000000"/>
+              </a:solidFill>
+              <a:effectLst/>
+              <a:uFillTx/>
+              <a:latin typeface="Arial"/>
             </a:endParaRPr>
           </a:p>
         </p:txBody>
@@ -3509,7 +3888,7 @@
         <p:spPr>
           <a:xfrm>
             <a:off x="900000" y="1260000"/>
-            <a:ext cx="7920000" cy="3056400"/>
+            <a:ext cx="7919640" cy="3056040"/>
           </a:xfrm>
           <a:prstGeom prst="rect">
             <a:avLst/>
@@ -3534,7 +3913,7 @@
         <p:txBody>
           <a:bodyPr/>
           <a:p>
-            <a:fld id="{DFF081DD-1B2F-4BC0-8768-F2F6A1D8D0CF}" type="slidenum">
+            <a:fld id="{C0263FAD-63F9-4214-93E4-2FBD024C3153}" type="slidenum">
               <a:t>3</a:t>
             </a:fld>
           </a:p>
@@ -3583,7 +3962,7 @@
         <p:spPr>
           <a:xfrm>
             <a:off x="360000" y="225720"/>
-            <a:ext cx="9360000" cy="718920"/>
+            <a:ext cx="9359640" cy="718560"/>
           </a:xfrm>
           <a:prstGeom prst="rect">
             <a:avLst/>
@@ -3599,7 +3978,13 @@
           </a:bodyPr>
           <a:p>
             <a:pPr indent="0" algn="ctr">
+              <a:lnSpc>
+                <a:spcPct val="100000"/>
+              </a:lnSpc>
               <a:buNone/>
+              <a:tabLst>
+                <a:tab algn="l" pos="0"/>
+              </a:tabLst>
             </a:pPr>
             <a:r>
               <a:rPr lang="en-GB" sz="5400" b="1" u="none" strike="noStrike">
@@ -3612,13 +3997,13 @@
               </a:rPr>
               <a:t>PROPOSED SOLUTIONS</a:t>
             </a:r>
-            <a:endParaRPr lang="en-GB" sz="5400" b="1" u="none" strike="noStrike">
-              <a:solidFill>
-                <a:srgbClr val="ffffff"/>
-              </a:solidFill>
-              <a:effectLst/>
-              <a:uFillTx/>
-              <a:latin typeface="Times New Roman"/>
+            <a:endParaRPr lang="en-GB" sz="5400" b="0" u="none" strike="noStrike">
+              <a:solidFill>
+                <a:srgbClr val="000000"/>
+              </a:solidFill>
+              <a:effectLst/>
+              <a:uFillTx/>
+              <a:latin typeface="Arial"/>
             </a:endParaRPr>
           </a:p>
         </p:txBody>
@@ -3636,7 +4021,7 @@
         <p:spPr>
           <a:xfrm>
             <a:off x="0" y="1260000"/>
-            <a:ext cx="9360000" cy="540000"/>
+            <a:ext cx="9359640" cy="539640"/>
           </a:xfrm>
           <a:prstGeom prst="rect">
             <a:avLst/>
@@ -3652,13 +4037,19 @@
           </a:bodyPr>
           <a:p>
             <a:pPr indent="0" algn="ctr">
+              <a:lnSpc>
+                <a:spcPct val="100000"/>
+              </a:lnSpc>
               <a:spcAft>
                 <a:spcPts val="1057"/>
               </a:spcAft>
               <a:buNone/>
-            </a:pPr>
-            <a:r>
-              <a:rPr lang="en-GB" sz="2800" b="1" u="none" strike="noStrike">
+              <a:tabLst>
+                <a:tab algn="l" pos="0"/>
+              </a:tabLst>
+            </a:pPr>
+            <a:r>
+              <a:rPr lang="en-GB" sz="2800" b="0" u="none" strike="noStrike">
                 <a:solidFill>
                   <a:srgbClr val="2c3e50"/>
                 </a:solidFill>
@@ -3668,13 +4059,13 @@
               </a:rPr>
               <a:t>An automated card issuance system, with:</a:t>
             </a:r>
-            <a:endParaRPr lang="en-GB" sz="2800" b="1" u="none" strike="noStrike">
-              <a:solidFill>
-                <a:srgbClr val="2c3e50"/>
-              </a:solidFill>
-              <a:effectLst/>
-              <a:uFillTx/>
-              <a:latin typeface="Times New Roman"/>
+            <a:endParaRPr lang="en-GB" sz="2800" b="0" u="none" strike="noStrike">
+              <a:solidFill>
+                <a:srgbClr val="000000"/>
+              </a:solidFill>
+              <a:effectLst/>
+              <a:uFillTx/>
+              <a:latin typeface="Arial"/>
             </a:endParaRPr>
           </a:p>
         </p:txBody>
@@ -3688,7 +4079,7 @@
         <p:spPr>
           <a:xfrm>
             <a:off x="540000" y="1800000"/>
-            <a:ext cx="3780000" cy="1440000"/>
+            <a:ext cx="3779640" cy="1439640"/>
           </a:xfrm>
           <a:prstGeom prst="flowChartAlternateProcess">
             <a:avLst/>
@@ -3703,7 +4094,7 @@
             <a:round/>
           </a:ln>
           <a:effectLst>
-            <a:outerShdw dist="101823" dir="2700000" rotWithShape="0">
+            <a:outerShdw dir="2700000" dist="101823" rotWithShape="0">
               <a:srgbClr val="808080"/>
             </a:outerShdw>
           </a:effectLst>
@@ -3732,16 +4123,17 @@
                 <a:effectLst/>
                 <a:uFillTx/>
                 <a:latin typeface="Times New Roman"/>
+                <a:ea typeface="DejaVu Sans"/>
               </a:rPr>
               <a:t>Automated reliable dispensing:</a:t>
             </a:r>
             <a:endParaRPr lang="en-GB" sz="2000" b="0" u="none" strike="noStrike">
               <a:solidFill>
-                <a:srgbClr val="2c3e50"/>
-              </a:solidFill>
-              <a:effectLst/>
-              <a:uFillTx/>
-              <a:latin typeface="Noto Sans"/>
+                <a:srgbClr val="000000"/>
+              </a:solidFill>
+              <a:effectLst/>
+              <a:uFillTx/>
+              <a:latin typeface="Arial"/>
             </a:endParaRPr>
           </a:p>
           <a:p>
@@ -3758,16 +4150,17 @@
                 <a:effectLst/>
                 <a:uFillTx/>
                 <a:latin typeface="Times New Roman"/>
+                <a:ea typeface="DejaVu Sans"/>
               </a:rPr>
               <a:t>Sorts and distributes cards </a:t>
             </a:r>
             <a:endParaRPr lang="en-GB" sz="2000" b="0" u="none" strike="noStrike">
               <a:solidFill>
-                <a:srgbClr val="2c3e50"/>
-              </a:solidFill>
-              <a:effectLst/>
-              <a:uFillTx/>
-              <a:latin typeface="Noto Sans"/>
+                <a:srgbClr val="000000"/>
+              </a:solidFill>
+              <a:effectLst/>
+              <a:uFillTx/>
+              <a:latin typeface="Arial"/>
             </a:endParaRPr>
           </a:p>
           <a:p>
@@ -3784,16 +4177,17 @@
                 <a:effectLst/>
                 <a:uFillTx/>
                 <a:latin typeface="Times New Roman"/>
+                <a:ea typeface="DejaVu Sans"/>
               </a:rPr>
               <a:t>24/7 with real-time control</a:t>
             </a:r>
             <a:endParaRPr lang="en-GB" sz="2000" b="0" u="none" strike="noStrike">
               <a:solidFill>
-                <a:srgbClr val="2c3e50"/>
-              </a:solidFill>
-              <a:effectLst/>
-              <a:uFillTx/>
-              <a:latin typeface="Noto Sans"/>
+                <a:srgbClr val="000000"/>
+              </a:solidFill>
+              <a:effectLst/>
+              <a:uFillTx/>
+              <a:latin typeface="Arial"/>
             </a:endParaRPr>
           </a:p>
         </p:txBody>
@@ -3807,7 +4201,7 @@
         <p:spPr>
           <a:xfrm>
             <a:off x="540000" y="3420000"/>
-            <a:ext cx="3780000" cy="1620000"/>
+            <a:ext cx="3779640" cy="1619640"/>
           </a:xfrm>
           <a:prstGeom prst="flowChartAlternateProcess">
             <a:avLst/>
@@ -3822,7 +4216,7 @@
             <a:round/>
           </a:ln>
           <a:effectLst>
-            <a:outerShdw dist="101823" dir="2700000" rotWithShape="0">
+            <a:outerShdw dir="2700000" dist="101823" rotWithShape="0">
               <a:srgbClr val="808080"/>
             </a:outerShdw>
           </a:effectLst>
@@ -3851,16 +4245,17 @@
                 <a:effectLst/>
                 <a:uFillTx/>
                 <a:latin typeface="Times New Roman"/>
+                <a:ea typeface="DejaVu Sans"/>
               </a:rPr>
               <a:t>Computer Vision:</a:t>
             </a:r>
             <a:endParaRPr lang="en-GB" sz="2000" b="0" u="none" strike="noStrike">
               <a:solidFill>
-                <a:srgbClr val="2c3e50"/>
-              </a:solidFill>
-              <a:effectLst/>
-              <a:uFillTx/>
-              <a:latin typeface="Times New Roman"/>
+                <a:srgbClr val="000000"/>
+              </a:solidFill>
+              <a:effectLst/>
+              <a:uFillTx/>
+              <a:latin typeface="Arial"/>
             </a:endParaRPr>
           </a:p>
           <a:p>
@@ -3877,16 +4272,17 @@
                 <a:effectLst/>
                 <a:uFillTx/>
                 <a:latin typeface="Times New Roman"/>
+                <a:ea typeface="DejaVu Sans"/>
               </a:rPr>
               <a:t>Automated card details verification</a:t>
             </a:r>
             <a:endParaRPr lang="en-GB" sz="2000" b="0" u="none" strike="noStrike">
               <a:solidFill>
-                <a:srgbClr val="2c3e50"/>
-              </a:solidFill>
-              <a:effectLst/>
-              <a:uFillTx/>
-              <a:latin typeface="Times New Roman"/>
+                <a:srgbClr val="000000"/>
+              </a:solidFill>
+              <a:effectLst/>
+              <a:uFillTx/>
+              <a:latin typeface="Arial"/>
             </a:endParaRPr>
           </a:p>
           <a:p>
@@ -3903,16 +4299,17 @@
                 <a:effectLst/>
                 <a:uFillTx/>
                 <a:latin typeface="Times New Roman"/>
+                <a:ea typeface="DejaVu Sans"/>
               </a:rPr>
               <a:t>for sorting and distribution</a:t>
             </a:r>
             <a:endParaRPr lang="en-GB" sz="2000" b="0" u="none" strike="noStrike">
               <a:solidFill>
-                <a:srgbClr val="2c3e50"/>
-              </a:solidFill>
-              <a:effectLst/>
-              <a:uFillTx/>
-              <a:latin typeface="Times New Roman"/>
+                <a:srgbClr val="000000"/>
+              </a:solidFill>
+              <a:effectLst/>
+              <a:uFillTx/>
+              <a:latin typeface="Arial"/>
             </a:endParaRPr>
           </a:p>
         </p:txBody>
@@ -3926,7 +4323,7 @@
         <p:spPr>
           <a:xfrm>
             <a:off x="5040000" y="1800000"/>
-            <a:ext cx="3780000" cy="1440000"/>
+            <a:ext cx="3779640" cy="1439640"/>
           </a:xfrm>
           <a:prstGeom prst="flowChartAlternateProcess">
             <a:avLst/>
@@ -3941,7 +4338,7 @@
             <a:round/>
           </a:ln>
           <a:effectLst>
-            <a:outerShdw dist="101823" dir="2700000" rotWithShape="0">
+            <a:outerShdw dir="2700000" dist="101823" rotWithShape="0">
               <a:srgbClr val="808080"/>
             </a:outerShdw>
           </a:effectLst>
@@ -3970,16 +4367,17 @@
                 <a:effectLst/>
                 <a:uFillTx/>
                 <a:latin typeface="Times New Roman"/>
+                <a:ea typeface="DejaVu Sans"/>
               </a:rPr>
               <a:t>Secure Authentication:</a:t>
             </a:r>
             <a:endParaRPr lang="en-GB" sz="2000" b="0" u="none" strike="noStrike">
               <a:solidFill>
-                <a:srgbClr val="2c3e50"/>
-              </a:solidFill>
-              <a:effectLst/>
-              <a:uFillTx/>
-              <a:latin typeface="Noto Sans"/>
+                <a:srgbClr val="000000"/>
+              </a:solidFill>
+              <a:effectLst/>
+              <a:uFillTx/>
+              <a:latin typeface="Arial"/>
             </a:endParaRPr>
           </a:p>
           <a:p>
@@ -3996,16 +4394,17 @@
                 <a:effectLst/>
                 <a:uFillTx/>
                 <a:latin typeface="Times New Roman"/>
+                <a:ea typeface="DejaVu Sans"/>
               </a:rPr>
               <a:t>OTP and PIN for student </a:t>
             </a:r>
             <a:endParaRPr lang="en-GB" sz="2000" b="0" u="none" strike="noStrike">
               <a:solidFill>
-                <a:srgbClr val="2c3e50"/>
-              </a:solidFill>
-              <a:effectLst/>
-              <a:uFillTx/>
-              <a:latin typeface="Noto Sans"/>
+                <a:srgbClr val="000000"/>
+              </a:solidFill>
+              <a:effectLst/>
+              <a:uFillTx/>
+              <a:latin typeface="Arial"/>
             </a:endParaRPr>
           </a:p>
           <a:p>
@@ -4022,16 +4421,17 @@
                 <a:effectLst/>
                 <a:uFillTx/>
                 <a:latin typeface="Times New Roman"/>
+                <a:ea typeface="DejaVu Sans"/>
               </a:rPr>
               <a:t>verification</a:t>
             </a:r>
             <a:endParaRPr lang="en-GB" sz="2000" b="0" u="none" strike="noStrike">
               <a:solidFill>
-                <a:srgbClr val="2c3e50"/>
-              </a:solidFill>
-              <a:effectLst/>
-              <a:uFillTx/>
-              <a:latin typeface="Noto Sans"/>
+                <a:srgbClr val="000000"/>
+              </a:solidFill>
+              <a:effectLst/>
+              <a:uFillTx/>
+              <a:latin typeface="Arial"/>
             </a:endParaRPr>
           </a:p>
         </p:txBody>
@@ -4045,7 +4445,7 @@
         <p:spPr>
           <a:xfrm>
             <a:off x="5040000" y="3420000"/>
-            <a:ext cx="3780000" cy="1620000"/>
+            <a:ext cx="3779640" cy="1619640"/>
           </a:xfrm>
           <a:prstGeom prst="flowChartAlternateProcess">
             <a:avLst/>
@@ -4060,7 +4460,7 @@
             <a:round/>
           </a:ln>
           <a:effectLst>
-            <a:outerShdw dist="101823" dir="2700000" rotWithShape="0">
+            <a:outerShdw dir="2700000" dist="101823" rotWithShape="0">
               <a:srgbClr val="808080"/>
             </a:outerShdw>
           </a:effectLst>
@@ -4089,16 +4489,17 @@
                 <a:effectLst/>
                 <a:uFillTx/>
                 <a:latin typeface="Times New Roman"/>
+                <a:ea typeface="DejaVu Sans"/>
               </a:rPr>
               <a:t>Audit logging:</a:t>
             </a:r>
             <a:endParaRPr lang="en-GB" sz="2100" b="0" u="none" strike="noStrike">
               <a:solidFill>
-                <a:srgbClr val="2c3e50"/>
-              </a:solidFill>
-              <a:effectLst/>
-              <a:uFillTx/>
-              <a:latin typeface="Times New Roman"/>
+                <a:srgbClr val="000000"/>
+              </a:solidFill>
+              <a:effectLst/>
+              <a:uFillTx/>
+              <a:latin typeface="Arial"/>
             </a:endParaRPr>
           </a:p>
           <a:p>
@@ -4115,16 +4516,17 @@
                 <a:effectLst/>
                 <a:uFillTx/>
                 <a:latin typeface="Times New Roman"/>
+                <a:ea typeface="DejaVu Sans"/>
               </a:rPr>
               <a:t>Record all activities happening </a:t>
             </a:r>
             <a:endParaRPr lang="en-GB" sz="2100" b="0" u="none" strike="noStrike">
               <a:solidFill>
-                <a:srgbClr val="2c3e50"/>
-              </a:solidFill>
-              <a:effectLst/>
-              <a:uFillTx/>
-              <a:latin typeface="Times New Roman"/>
+                <a:srgbClr val="000000"/>
+              </a:solidFill>
+              <a:effectLst/>
+              <a:uFillTx/>
+              <a:latin typeface="Arial"/>
             </a:endParaRPr>
           </a:p>
           <a:p>
@@ -4141,16 +4543,17 @@
                 <a:effectLst/>
                 <a:uFillTx/>
                 <a:latin typeface="Times New Roman"/>
+                <a:ea typeface="DejaVu Sans"/>
               </a:rPr>
               <a:t>for debugging and tracking</a:t>
             </a:r>
             <a:endParaRPr lang="en-GB" sz="2100" b="0" u="none" strike="noStrike">
               <a:solidFill>
-                <a:srgbClr val="2c3e50"/>
-              </a:solidFill>
-              <a:effectLst/>
-              <a:uFillTx/>
-              <a:latin typeface="Times New Roman"/>
+                <a:srgbClr val="000000"/>
+              </a:solidFill>
+              <a:effectLst/>
+              <a:uFillTx/>
+              <a:latin typeface="Arial"/>
             </a:endParaRPr>
           </a:p>
         </p:txBody>
@@ -4169,7 +4572,7 @@
         <p:txBody>
           <a:bodyPr/>
           <a:p>
-            <a:fld id="{C860AFE8-5AF0-48EA-9F51-41DB2E5EAA3F}" type="slidenum">
+            <a:fld id="{617D7274-93A2-435F-8D4E-9A34A197AC36}" type="slidenum">
               <a:t>4</a:t>
             </a:fld>
           </a:p>
@@ -4218,7 +4621,7 @@
         <p:spPr>
           <a:xfrm>
             <a:off x="360000" y="225720"/>
-            <a:ext cx="9360000" cy="718920"/>
+            <a:ext cx="9359640" cy="718560"/>
           </a:xfrm>
           <a:prstGeom prst="rect">
             <a:avLst/>
@@ -4234,7 +4637,13 @@
           </a:bodyPr>
           <a:p>
             <a:pPr indent="0" algn="ctr">
+              <a:lnSpc>
+                <a:spcPct val="100000"/>
+              </a:lnSpc>
               <a:buNone/>
+              <a:tabLst>
+                <a:tab algn="l" pos="0"/>
+              </a:tabLst>
             </a:pPr>
             <a:r>
               <a:rPr lang="en-GB" sz="5400" b="1" u="none" strike="noStrike">
@@ -4247,13 +4656,13 @@
               </a:rPr>
               <a:t>OBJECTIVES</a:t>
             </a:r>
-            <a:endParaRPr lang="en-GB" sz="5400" b="1" u="none" strike="noStrike">
-              <a:solidFill>
-                <a:srgbClr val="ffffff"/>
-              </a:solidFill>
-              <a:effectLst/>
-              <a:uFillTx/>
-              <a:latin typeface="Times New Roman"/>
+            <a:endParaRPr lang="en-GB" sz="5400" b="0" u="none" strike="noStrike">
+              <a:solidFill>
+                <a:srgbClr val="000000"/>
+              </a:solidFill>
+              <a:effectLst/>
+              <a:uFillTx/>
+              <a:latin typeface="Arial"/>
             </a:endParaRPr>
           </a:p>
         </p:txBody>
@@ -4271,7 +4680,7 @@
         <p:spPr>
           <a:xfrm>
             <a:off x="360000" y="1260000"/>
-            <a:ext cx="9360000" cy="3780000"/>
+            <a:ext cx="9359640" cy="3779640"/>
           </a:xfrm>
           <a:prstGeom prst="rect">
             <a:avLst/>
@@ -4283,7 +4692,7 @@
         </p:spPr>
         <p:txBody>
           <a:bodyPr lIns="0" rIns="0" tIns="0" bIns="0" anchor="t">
-            <a:normAutofit/>
+            <a:normAutofit lnSpcReduction="9999"/>
           </a:bodyPr>
           <a:p>
             <a:pPr indent="0">
@@ -4294,9 +4703,12 @@
                 <a:spcPts val="1057"/>
               </a:spcAft>
               <a:buNone/>
-            </a:pPr>
-            <a:r>
-              <a:rPr lang="en-GB" sz="2400" b="1" u="none" strike="noStrike">
+              <a:tabLst>
+                <a:tab algn="l" pos="0"/>
+              </a:tabLst>
+            </a:pPr>
+            <a:r>
+              <a:rPr lang="en-GB" sz="2400" b="0" u="none" strike="noStrike">
                 <a:solidFill>
                   <a:srgbClr val="2c3e50"/>
                 </a:solidFill>
@@ -4306,13 +4718,13 @@
               </a:rPr>
               <a:t>Main Objective:</a:t>
             </a:r>
-            <a:endParaRPr lang="en-GB" sz="2400" b="1" u="none" strike="noStrike">
-              <a:solidFill>
-                <a:srgbClr val="2c3e50"/>
-              </a:solidFill>
-              <a:effectLst/>
-              <a:uFillTx/>
-              <a:latin typeface="Times New Roman"/>
+            <a:endParaRPr lang="en-GB" sz="2400" b="0" u="none" strike="noStrike">
+              <a:solidFill>
+                <a:srgbClr val="000000"/>
+              </a:solidFill>
+              <a:effectLst/>
+              <a:uFillTx/>
+              <a:latin typeface="Arial"/>
             </a:endParaRPr>
           </a:p>
           <a:p>
@@ -4329,9 +4741,12 @@
               <a:buSzPct val="45000"/>
               <a:buFont typeface="Wingdings" charset="2"/>
               <a:buChar char=""/>
-            </a:pPr>
-            <a:r>
-              <a:rPr lang="en-GB" sz="2400" b="1" u="none" strike="noStrike">
+              <a:tabLst>
+                <a:tab algn="l" pos="0"/>
+              </a:tabLst>
+            </a:pPr>
+            <a:r>
+              <a:rPr lang="en-GB" sz="2400" b="0" u="none" strike="noStrike">
                 <a:solidFill>
                   <a:srgbClr val="2c3e50"/>
                 </a:solidFill>
@@ -4341,13 +4756,13 @@
               </a:rPr>
               <a:t>To design and implement an Automated ID card Issuance System</a:t>
             </a:r>
-            <a:endParaRPr lang="en-GB" sz="2400" b="1" u="none" strike="noStrike">
-              <a:solidFill>
-                <a:srgbClr val="2c3e50"/>
-              </a:solidFill>
-              <a:effectLst/>
-              <a:uFillTx/>
-              <a:latin typeface="Times New Roman"/>
+            <a:endParaRPr lang="en-GB" sz="2400" b="0" u="none" strike="noStrike">
+              <a:solidFill>
+                <a:srgbClr val="000000"/>
+              </a:solidFill>
+              <a:effectLst/>
+              <a:uFillTx/>
+              <a:latin typeface="Arial"/>
             </a:endParaRPr>
           </a:p>
           <a:p>
@@ -4359,9 +4774,12 @@
                 <a:spcPts val="1057"/>
               </a:spcAft>
               <a:buNone/>
-            </a:pPr>
-            <a:r>
-              <a:rPr lang="en-GB" sz="2400" b="1" u="none" strike="noStrike">
+              <a:tabLst>
+                <a:tab algn="l" pos="0"/>
+              </a:tabLst>
+            </a:pPr>
+            <a:r>
+              <a:rPr lang="en-GB" sz="2400" b="0" u="none" strike="noStrike">
                 <a:solidFill>
                   <a:srgbClr val="2c3e50"/>
                 </a:solidFill>
@@ -4371,13 +4789,13 @@
               </a:rPr>
               <a:t>Specific Objectives:</a:t>
             </a:r>
-            <a:endParaRPr lang="en-GB" sz="2400" b="1" u="none" strike="noStrike">
-              <a:solidFill>
-                <a:srgbClr val="2c3e50"/>
-              </a:solidFill>
-              <a:effectLst/>
-              <a:uFillTx/>
-              <a:latin typeface="Times New Roman"/>
+            <a:endParaRPr lang="en-GB" sz="2400" b="0" u="none" strike="noStrike">
+              <a:solidFill>
+                <a:srgbClr val="000000"/>
+              </a:solidFill>
+              <a:effectLst/>
+              <a:uFillTx/>
+              <a:latin typeface="Arial"/>
             </a:endParaRPr>
           </a:p>
           <a:p>
@@ -4394,9 +4812,12 @@
               <a:buSzPct val="45000"/>
               <a:buFont typeface="Wingdings" charset="2"/>
               <a:buChar char=""/>
-            </a:pPr>
-            <a:r>
-              <a:rPr lang="en-GB" sz="2400" b="1" u="none" strike="noStrike">
+              <a:tabLst>
+                <a:tab algn="l" pos="0"/>
+              </a:tabLst>
+            </a:pPr>
+            <a:r>
+              <a:rPr lang="en-GB" sz="2400" b="0" u="none" strike="noStrike">
                 <a:solidFill>
                   <a:srgbClr val="2c3e50"/>
                 </a:solidFill>
@@ -4406,13 +4827,13 @@
               </a:rPr>
               <a:t>To implement robust authentication </a:t>
             </a:r>
-            <a:endParaRPr lang="en-GB" sz="2400" b="1" u="none" strike="noStrike">
-              <a:solidFill>
-                <a:srgbClr val="2c3e50"/>
-              </a:solidFill>
-              <a:effectLst/>
-              <a:uFillTx/>
-              <a:latin typeface="Times New Roman"/>
+            <a:endParaRPr lang="en-GB" sz="2400" b="0" u="none" strike="noStrike">
+              <a:solidFill>
+                <a:srgbClr val="000000"/>
+              </a:solidFill>
+              <a:effectLst/>
+              <a:uFillTx/>
+              <a:latin typeface="Arial"/>
             </a:endParaRPr>
           </a:p>
           <a:p>
@@ -4429,9 +4850,12 @@
               <a:buSzPct val="45000"/>
               <a:buFont typeface="Wingdings" charset="2"/>
               <a:buChar char=""/>
-            </a:pPr>
-            <a:r>
-              <a:rPr lang="en-GB" sz="2400" b="1" u="none" strike="noStrike">
+              <a:tabLst>
+                <a:tab algn="l" pos="0"/>
+              </a:tabLst>
+            </a:pPr>
+            <a:r>
+              <a:rPr lang="en-GB" sz="2400" b="0" u="none" strike="noStrike">
                 <a:solidFill>
                   <a:srgbClr val="2c3e50"/>
                 </a:solidFill>
@@ -4441,13 +4865,13 @@
               </a:rPr>
               <a:t>To implement an actuator control system</a:t>
             </a:r>
-            <a:endParaRPr lang="en-GB" sz="2400" b="1" u="none" strike="noStrike">
-              <a:solidFill>
-                <a:srgbClr val="2c3e50"/>
-              </a:solidFill>
-              <a:effectLst/>
-              <a:uFillTx/>
-              <a:latin typeface="Times New Roman"/>
+            <a:endParaRPr lang="en-GB" sz="2400" b="0" u="none" strike="noStrike">
+              <a:solidFill>
+                <a:srgbClr val="000000"/>
+              </a:solidFill>
+              <a:effectLst/>
+              <a:uFillTx/>
+              <a:latin typeface="Arial"/>
             </a:endParaRPr>
           </a:p>
           <a:p>
@@ -4464,9 +4888,12 @@
               <a:buSzPct val="45000"/>
               <a:buFont typeface="Wingdings" charset="2"/>
               <a:buChar char=""/>
-            </a:pPr>
-            <a:r>
-              <a:rPr lang="en-GB" sz="2400" b="1" u="none" strike="noStrike">
+              <a:tabLst>
+                <a:tab algn="l" pos="0"/>
+              </a:tabLst>
+            </a:pPr>
+            <a:r>
+              <a:rPr lang="en-GB" sz="2400" b="0" u="none" strike="noStrike">
                 <a:solidFill>
                   <a:srgbClr val="2c3e50"/>
                 </a:solidFill>
@@ -4476,13 +4903,13 @@
               </a:rPr>
               <a:t>To enforce security policy and audit logging</a:t>
             </a:r>
-            <a:endParaRPr lang="en-GB" sz="2400" b="1" u="none" strike="noStrike">
-              <a:solidFill>
-                <a:srgbClr val="2c3e50"/>
-              </a:solidFill>
-              <a:effectLst/>
-              <a:uFillTx/>
-              <a:latin typeface="Times New Roman"/>
+            <a:endParaRPr lang="en-GB" sz="2400" b="0" u="none" strike="noStrike">
+              <a:solidFill>
+                <a:srgbClr val="000000"/>
+              </a:solidFill>
+              <a:effectLst/>
+              <a:uFillTx/>
+              <a:latin typeface="Arial"/>
             </a:endParaRPr>
           </a:p>
         </p:txBody>
@@ -4501,7 +4928,7 @@
         <p:txBody>
           <a:bodyPr/>
           <a:p>
-            <a:fld id="{8C0E0C37-30DB-44D7-9486-56DC5235A98C}" type="slidenum">
+            <a:fld id="{548B3677-B242-4F52-8140-032A082791CA}" type="slidenum">
               <a:t>5</a:t>
             </a:fld>
           </a:p>
@@ -4550,7 +4977,7 @@
         <p:spPr>
           <a:xfrm>
             <a:off x="360000" y="225720"/>
-            <a:ext cx="9360000" cy="718920"/>
+            <a:ext cx="9359640" cy="718560"/>
           </a:xfrm>
           <a:prstGeom prst="rect">
             <a:avLst/>
@@ -4566,7 +4993,13 @@
           </a:bodyPr>
           <a:p>
             <a:pPr indent="0" algn="ctr">
+              <a:lnSpc>
+                <a:spcPct val="100000"/>
+              </a:lnSpc>
               <a:buNone/>
+              <a:tabLst>
+                <a:tab algn="l" pos="0"/>
+              </a:tabLst>
             </a:pPr>
             <a:r>
               <a:rPr lang="en-GB" sz="5400" b="1" u="none" strike="noStrike">
@@ -4579,13 +5012,13 @@
               </a:rPr>
               <a:t>SYSTEM ARCHITECTURE</a:t>
             </a:r>
-            <a:endParaRPr lang="en-GB" sz="5400" b="1" u="none" strike="noStrike">
-              <a:solidFill>
-                <a:srgbClr val="ffffff"/>
-              </a:solidFill>
-              <a:effectLst/>
-              <a:uFillTx/>
-              <a:latin typeface="Times New Roman"/>
+            <a:endParaRPr lang="en-GB" sz="5400" b="0" u="none" strike="noStrike">
+              <a:solidFill>
+                <a:srgbClr val="000000"/>
+              </a:solidFill>
+              <a:effectLst/>
+              <a:uFillTx/>
+              <a:latin typeface="Arial"/>
             </a:endParaRPr>
           </a:p>
         </p:txBody>
@@ -4603,7 +5036,7 @@
         <p:spPr>
           <a:xfrm>
             <a:off x="360000" y="4140000"/>
-            <a:ext cx="9360000" cy="1125000"/>
+            <a:ext cx="9359640" cy="1124640"/>
           </a:xfrm>
           <a:prstGeom prst="rect">
             <a:avLst/>
@@ -4633,7 +5066,7 @@
               <a:buChar char=""/>
             </a:pPr>
             <a:r>
-              <a:rPr lang="en-GB" sz="2200" b="1" u="none" strike="noStrike">
+              <a:rPr lang="en-GB" sz="2200" b="0" u="none" strike="noStrike">
                 <a:solidFill>
                   <a:srgbClr val="2c3e50"/>
                 </a:solidFill>
@@ -4643,13 +5076,13 @@
               </a:rPr>
               <a:t>High – level controller manages authentication, UI, database and computer vision while low – level controller manages real – time controls and sensor integration.</a:t>
             </a:r>
-            <a:endParaRPr lang="en-GB" sz="2200" b="1" u="none" strike="noStrike">
-              <a:solidFill>
-                <a:srgbClr val="2c3e50"/>
-              </a:solidFill>
-              <a:effectLst/>
-              <a:uFillTx/>
-              <a:latin typeface="Times New Roman"/>
+            <a:endParaRPr lang="en-GB" sz="2200" b="0" u="none" strike="noStrike">
+              <a:solidFill>
+                <a:srgbClr val="000000"/>
+              </a:solidFill>
+              <a:effectLst/>
+              <a:uFillTx/>
+              <a:latin typeface="Arial"/>
             </a:endParaRPr>
           </a:p>
         </p:txBody>
@@ -4667,7 +5100,7 @@
         <p:spPr>
           <a:xfrm>
             <a:off x="180000" y="1257480"/>
-            <a:ext cx="9540000" cy="2882520"/>
+            <a:ext cx="9539640" cy="2882160"/>
           </a:xfrm>
           <a:prstGeom prst="rect">
             <a:avLst/>
@@ -4692,7 +5125,7 @@
         <p:txBody>
           <a:bodyPr/>
           <a:p>
-            <a:fld id="{5D131772-599A-43FB-8F6F-15FE65044B7C}" type="slidenum">
+            <a:fld id="{859A5480-EEC9-43D8-85CC-27FF4C8A17F2}" type="slidenum">
               <a:t>6</a:t>
             </a:fld>
           </a:p>
@@ -4741,7 +5174,7 @@
         <p:spPr>
           <a:xfrm>
             <a:off x="360000" y="225720"/>
-            <a:ext cx="9360000" cy="718920"/>
+            <a:ext cx="9359640" cy="718560"/>
           </a:xfrm>
           <a:prstGeom prst="rect">
             <a:avLst/>
@@ -4757,7 +5190,13 @@
           </a:bodyPr>
           <a:p>
             <a:pPr indent="0" algn="ctr">
+              <a:lnSpc>
+                <a:spcPct val="100000"/>
+              </a:lnSpc>
               <a:buNone/>
+              <a:tabLst>
+                <a:tab algn="l" pos="0"/>
+              </a:tabLst>
             </a:pPr>
             <a:r>
               <a:rPr lang="en-GB" sz="5400" b="1" u="none" strike="noStrike">
@@ -4770,13 +5209,13 @@
               </a:rPr>
               <a:t>FUNCTIONAL WORKFLOW</a:t>
             </a:r>
-            <a:endParaRPr lang="en-GB" sz="5400" b="1" u="none" strike="noStrike">
-              <a:solidFill>
-                <a:srgbClr val="ffffff"/>
-              </a:solidFill>
-              <a:effectLst/>
-              <a:uFillTx/>
-              <a:latin typeface="Times New Roman"/>
+            <a:endParaRPr lang="en-GB" sz="5400" b="0" u="none" strike="noStrike">
+              <a:solidFill>
+                <a:srgbClr val="000000"/>
+              </a:solidFill>
+              <a:effectLst/>
+              <a:uFillTx/>
+              <a:latin typeface="Arial"/>
             </a:endParaRPr>
           </a:p>
         </p:txBody>
@@ -4794,7 +5233,7 @@
         <p:spPr>
           <a:xfrm>
             <a:off x="1082880" y="1080000"/>
-            <a:ext cx="8277120" cy="4350240"/>
+            <a:ext cx="8276760" cy="4349880"/>
           </a:xfrm>
           <a:prstGeom prst="rect">
             <a:avLst/>
@@ -4819,7 +5258,7 @@
         <p:txBody>
           <a:bodyPr/>
           <a:p>
-            <a:fld id="{B4248952-66DE-4921-A63E-01CC3017FB33}" type="slidenum">
+            <a:fld id="{F5705930-1EF2-4638-84E6-D7C5A0562D7B}" type="slidenum">
               <a:t>7</a:t>
             </a:fld>
           </a:p>
@@ -4868,7 +5307,7 @@
         <p:spPr>
           <a:xfrm>
             <a:off x="360000" y="225720"/>
-            <a:ext cx="9360000" cy="718920"/>
+            <a:ext cx="9359640" cy="718560"/>
           </a:xfrm>
           <a:prstGeom prst="rect">
             <a:avLst/>
@@ -4884,7 +5323,13 @@
           </a:bodyPr>
           <a:p>
             <a:pPr indent="0" algn="ctr">
+              <a:lnSpc>
+                <a:spcPct val="100000"/>
+              </a:lnSpc>
               <a:buNone/>
+              <a:tabLst>
+                <a:tab algn="l" pos="0"/>
+              </a:tabLst>
             </a:pPr>
             <a:r>
               <a:rPr lang="en-GB" sz="5400" b="1" u="none" strike="noStrike">
@@ -4897,13 +5342,13 @@
               </a:rPr>
               <a:t>FUNCTIONAL WORKFLOW</a:t>
             </a:r>
-            <a:endParaRPr lang="en-GB" sz="5400" b="1" u="none" strike="noStrike">
-              <a:solidFill>
-                <a:srgbClr val="ffffff"/>
-              </a:solidFill>
-              <a:effectLst/>
-              <a:uFillTx/>
-              <a:latin typeface="Times New Roman"/>
+            <a:endParaRPr lang="en-GB" sz="5400" b="0" u="none" strike="noStrike">
+              <a:solidFill>
+                <a:srgbClr val="000000"/>
+              </a:solidFill>
+              <a:effectLst/>
+              <a:uFillTx/>
+              <a:latin typeface="Arial"/>
             </a:endParaRPr>
           </a:p>
         </p:txBody>
@@ -4921,7 +5366,7 @@
         <p:spPr>
           <a:xfrm>
             <a:off x="180000" y="1260000"/>
-            <a:ext cx="3760920" cy="4140000"/>
+            <a:ext cx="3760560" cy="4139640"/>
           </a:xfrm>
           <a:prstGeom prst="rect">
             <a:avLst/>
@@ -4945,7 +5390,7 @@
         <p:spPr>
           <a:xfrm>
             <a:off x="4320000" y="1260000"/>
-            <a:ext cx="5652360" cy="4225320"/>
+            <a:ext cx="5652000" cy="4224960"/>
           </a:xfrm>
           <a:prstGeom prst="rect">
             <a:avLst/>
@@ -4970,7 +5415,7 @@
         <p:txBody>
           <a:bodyPr/>
           <a:p>
-            <a:fld id="{84259CA0-C183-4F4F-ACEA-9067C5A1869E}" type="slidenum">
+            <a:fld id="{6B571FA4-9866-4811-A676-CD2E8E893AEE}" type="slidenum">
               <a:t>8</a:t>
             </a:fld>
           </a:p>
@@ -5019,7 +5464,7 @@
         <p:spPr>
           <a:xfrm>
             <a:off x="360000" y="225720"/>
-            <a:ext cx="9360000" cy="718920"/>
+            <a:ext cx="9359640" cy="718560"/>
           </a:xfrm>
           <a:prstGeom prst="rect">
             <a:avLst/>
@@ -5035,7 +5480,13 @@
           </a:bodyPr>
           <a:p>
             <a:pPr indent="0">
+              <a:lnSpc>
+                <a:spcPct val="100000"/>
+              </a:lnSpc>
               <a:buNone/>
+              <a:tabLst>
+                <a:tab algn="l" pos="0"/>
+              </a:tabLst>
             </a:pPr>
             <a:r>
               <a:rPr lang="en-GB" sz="4800" b="1" u="none" strike="noStrike">
@@ -5048,13 +5499,13 @@
               </a:rPr>
               <a:t>COMPUTER VISION PIPELINE</a:t>
             </a:r>
-            <a:endParaRPr lang="en-GB" sz="4800" b="1" u="none" strike="noStrike">
-              <a:solidFill>
-                <a:srgbClr val="ffffff"/>
-              </a:solidFill>
-              <a:effectLst/>
-              <a:uFillTx/>
-              <a:latin typeface="Times New Roman"/>
+            <a:endParaRPr lang="en-GB" sz="4800" b="0" u="none" strike="noStrike">
+              <a:solidFill>
+                <a:srgbClr val="000000"/>
+              </a:solidFill>
+              <a:effectLst/>
+              <a:uFillTx/>
+              <a:latin typeface="Arial"/>
             </a:endParaRPr>
           </a:p>
         </p:txBody>
@@ -5072,7 +5523,7 @@
         <p:spPr>
           <a:xfrm>
             <a:off x="0" y="1186920"/>
-            <a:ext cx="10079640" cy="1333080"/>
+            <a:ext cx="10079280" cy="1332720"/>
           </a:xfrm>
           <a:prstGeom prst="rect">
             <a:avLst/>
@@ -5097,7 +5548,7 @@
         <p:spPr>
           <a:xfrm>
             <a:off x="156240" y="2776680"/>
-            <a:ext cx="2723760" cy="1903320"/>
+            <a:ext cx="2723400" cy="1902960"/>
           </a:xfrm>
           <a:prstGeom prst="rect">
             <a:avLst/>
@@ -5121,7 +5572,7 @@
         <p:spPr>
           <a:xfrm>
             <a:off x="3240000" y="2774520"/>
-            <a:ext cx="3021120" cy="1905480"/>
+            <a:ext cx="3020760" cy="1905120"/>
           </a:xfrm>
           <a:prstGeom prst="rect">
             <a:avLst/>
@@ -5145,7 +5596,7 @@
         <p:spPr>
           <a:xfrm>
             <a:off x="6621120" y="3240000"/>
-            <a:ext cx="3278880" cy="1103760"/>
+            <a:ext cx="3278520" cy="1103400"/>
           </a:xfrm>
           <a:prstGeom prst="rect">
             <a:avLst/>
@@ -5165,7 +5616,7 @@
         <p:spPr>
           <a:xfrm>
             <a:off x="2880000" y="3600000"/>
-            <a:ext cx="360000" cy="180000"/>
+            <a:ext cx="359640" cy="179640"/>
           </a:xfrm>
           <a:prstGeom prst="rightArrow">
             <a:avLst>
@@ -5194,7 +5645,11 @@
             <a:noAutofit/>
           </a:bodyPr>
           <a:p>
-            <a:pPr algn="ctr"/>
+            <a:pPr algn="ctr">
+              <a:lnSpc>
+                <a:spcPct val="100000"/>
+              </a:lnSpc>
+            </a:pPr>
             <a:endParaRPr lang="en-GB" sz="1800" b="0" u="none" strike="noStrike">
               <a:solidFill>
                 <a:srgbClr val="2c3e50"/>
@@ -5202,6 +5657,7 @@
               <a:effectLst/>
               <a:uFillTx/>
               <a:latin typeface="Noto Sans"/>
+              <a:ea typeface="DejaVu Sans"/>
             </a:endParaRPr>
           </a:p>
         </p:txBody>
@@ -5215,7 +5671,7 @@
         <p:spPr>
           <a:xfrm>
             <a:off x="6261120" y="3600000"/>
-            <a:ext cx="360000" cy="180000"/>
+            <a:ext cx="359640" cy="179640"/>
           </a:xfrm>
           <a:prstGeom prst="rightArrow">
             <a:avLst>
@@ -5244,7 +5700,11 @@
             <a:noAutofit/>
           </a:bodyPr>
           <a:p>
-            <a:pPr algn="ctr"/>
+            <a:pPr algn="ctr">
+              <a:lnSpc>
+                <a:spcPct val="100000"/>
+              </a:lnSpc>
+            </a:pPr>
             <a:endParaRPr lang="en-GB" sz="1800" b="0" u="none" strike="noStrike">
               <a:solidFill>
                 <a:srgbClr val="2c3e50"/>
@@ -5252,6 +5712,7 @@
               <a:effectLst/>
               <a:uFillTx/>
               <a:latin typeface="Noto Sans"/>
+              <a:ea typeface="DejaVu Sans"/>
             </a:endParaRPr>
           </a:p>
         </p:txBody>
@@ -5270,7 +5731,7 @@
         <p:txBody>
           <a:bodyPr/>
           <a:p>
-            <a:fld id="{8502D4F5-B2C1-42F4-9F15-D0A2E478EEE0}" type="slidenum">
+            <a:fld id="{6CB4BD5D-9324-4C89-AE5C-97F7BB2D3A07}" type="slidenum">
               <a:t>9</a:t>
             </a:fld>
           </a:p>

</xml_diff>

<commit_message>
docs: 3d files for design added
</commit_message>
<xml_diff>
--- a/docs/uni-submission/end-semester-one.pptx
+++ b/docs/uni-submission/end-semester-one.pptx
@@ -50,7 +50,7 @@
         <p:spPr>
           <a:xfrm>
             <a:off x="0" y="5400000"/>
-            <a:ext cx="10079640" cy="269640"/>
+            <a:ext cx="10079280" cy="269280"/>
           </a:xfrm>
           <a:prstGeom prst="rect">
             <a:avLst/>
@@ -99,7 +99,7 @@
         <p:spPr>
           <a:xfrm>
             <a:off x="0" y="0"/>
-            <a:ext cx="10079640" cy="1214640"/>
+            <a:ext cx="10079280" cy="1214280"/>
           </a:xfrm>
           <a:prstGeom prst="rect">
             <a:avLst/>
@@ -148,7 +148,7 @@
         <p:spPr>
           <a:xfrm>
             <a:off x="9315000" y="5175000"/>
-            <a:ext cx="449640" cy="449640"/>
+            <a:ext cx="449280" cy="449280"/>
           </a:xfrm>
           <a:prstGeom prst="ellipse">
             <a:avLst/>
@@ -203,7 +203,7 @@
         <p:spPr>
           <a:xfrm>
             <a:off x="360000" y="225720"/>
-            <a:ext cx="9359640" cy="718560"/>
+            <a:ext cx="9359280" cy="718200"/>
           </a:xfrm>
           <a:prstGeom prst="rect">
             <a:avLst/>
@@ -273,7 +273,7 @@
         <p:spPr>
           <a:xfrm>
             <a:off x="360000" y="1485000"/>
-            <a:ext cx="9359640" cy="3779640"/>
+            <a:ext cx="9359280" cy="3779280"/>
           </a:xfrm>
           <a:prstGeom prst="rect">
             <a:avLst/>
@@ -547,7 +547,7 @@
         <p:spPr>
           <a:xfrm>
             <a:off x="360000" y="5400000"/>
-            <a:ext cx="2879640" cy="311400"/>
+            <a:ext cx="2879280" cy="311400"/>
           </a:xfrm>
           <a:prstGeom prst="rect">
             <a:avLst/>
@@ -625,7 +625,7 @@
         <p:spPr>
           <a:xfrm>
             <a:off x="3420000" y="5400000"/>
-            <a:ext cx="3239640" cy="311400"/>
+            <a:ext cx="3239280" cy="311400"/>
           </a:xfrm>
           <a:prstGeom prst="rect">
             <a:avLst/>
@@ -703,7 +703,7 @@
         <p:spPr>
           <a:xfrm>
             <a:off x="9180000" y="5262480"/>
-            <a:ext cx="719640" cy="274680"/>
+            <a:ext cx="719280" cy="274680"/>
           </a:xfrm>
           <a:prstGeom prst="rect">
             <a:avLst/>
@@ -746,7 +746,7 @@
                 <a:tab algn="l" pos="0"/>
               </a:tabLst>
             </a:pPr>
-            <a:fld id="{475168E3-74F1-4CF9-BC74-D25E713E963A}" type="slidenum">
+            <a:fld id="{6866B699-A1B6-4387-BD94-7250DDE24055}" type="slidenum">
               <a:rPr lang="en-GB" sz="1800" b="1" u="none" strike="noStrike">
                 <a:solidFill>
                   <a:srgbClr val="ffffff"/>
@@ -799,7 +799,7 @@
         <p:spPr>
           <a:xfrm>
             <a:off x="0" y="0"/>
-            <a:ext cx="10079640" cy="5669640"/>
+            <a:ext cx="10079280" cy="5669280"/>
           </a:xfrm>
           <a:prstGeom prst="rect">
             <a:avLst/>
@@ -848,7 +848,7 @@
         <p:spPr>
           <a:xfrm>
             <a:off x="0" y="0"/>
-            <a:ext cx="10079640" cy="3779640"/>
+            <a:ext cx="10079280" cy="3779280"/>
           </a:xfrm>
           <a:prstGeom prst="rect">
             <a:avLst/>
@@ -903,7 +903,7 @@
         <p:spPr>
           <a:xfrm>
             <a:off x="360000" y="2835000"/>
-            <a:ext cx="9359640" cy="718560"/>
+            <a:ext cx="9359280" cy="718200"/>
           </a:xfrm>
           <a:prstGeom prst="rect">
             <a:avLst/>
@@ -962,7 +962,7 @@
         <p:spPr>
           <a:xfrm>
             <a:off x="360000" y="3915000"/>
-            <a:ext cx="9359640" cy="1484640"/>
+            <a:ext cx="9359280" cy="1484280"/>
           </a:xfrm>
           <a:prstGeom prst="rect">
             <a:avLst/>
@@ -1222,7 +1222,7 @@
         <p:spPr>
           <a:xfrm>
             <a:off x="360000" y="5400000"/>
-            <a:ext cx="2879640" cy="311400"/>
+            <a:ext cx="2879280" cy="311400"/>
           </a:xfrm>
           <a:prstGeom prst="rect">
             <a:avLst/>
@@ -1300,7 +1300,7 @@
         <p:spPr>
           <a:xfrm>
             <a:off x="3420000" y="5400000"/>
-            <a:ext cx="3239640" cy="311400"/>
+            <a:ext cx="3239280" cy="311400"/>
           </a:xfrm>
           <a:prstGeom prst="rect">
             <a:avLst/>
@@ -1378,7 +1378,7 @@
         <p:spPr>
           <a:xfrm>
             <a:off x="9180000" y="5262480"/>
-            <a:ext cx="719640" cy="274680"/>
+            <a:ext cx="719280" cy="274680"/>
           </a:xfrm>
           <a:prstGeom prst="rect">
             <a:avLst/>
@@ -1421,7 +1421,7 @@
                 <a:tab algn="l" pos="0"/>
               </a:tabLst>
             </a:pPr>
-            <a:fld id="{F8BBB361-2B3A-43F6-AE89-F061E6590BFF}" type="slidenum">
+            <a:fld id="{FA592C77-C6C9-4973-972A-F8F389AA96D6}" type="slidenum">
               <a:rPr lang="en-GB" sz="1800" b="1" u="none" strike="noStrike">
                 <a:solidFill>
                   <a:srgbClr val="ffffff"/>
@@ -1474,7 +1474,7 @@
         <p:spPr>
           <a:xfrm>
             <a:off x="0" y="0"/>
-            <a:ext cx="10079640" cy="5669640"/>
+            <a:ext cx="10079280" cy="5669280"/>
           </a:xfrm>
           <a:prstGeom prst="rect">
             <a:avLst/>
@@ -1523,7 +1523,7 @@
         <p:spPr>
           <a:xfrm>
             <a:off x="2520000" y="1350000"/>
-            <a:ext cx="5039640" cy="1889640"/>
+            <a:ext cx="5039280" cy="1889280"/>
           </a:xfrm>
           <a:prstGeom prst="wedgeRectCallout">
             <a:avLst>
@@ -1582,7 +1582,7 @@
         <p:spPr>
           <a:xfrm>
             <a:off x="2700000" y="1485000"/>
-            <a:ext cx="4679640" cy="1619640"/>
+            <a:ext cx="4679280" cy="1619280"/>
           </a:xfrm>
           <a:prstGeom prst="rect">
             <a:avLst/>
@@ -1641,7 +1641,7 @@
         <p:spPr>
           <a:xfrm>
             <a:off x="3420000" y="3240000"/>
-            <a:ext cx="6299640" cy="1619640"/>
+            <a:ext cx="6299280" cy="1619280"/>
           </a:xfrm>
           <a:prstGeom prst="rect">
             <a:avLst/>
@@ -1901,7 +1901,7 @@
         <p:spPr>
           <a:xfrm>
             <a:off x="360000" y="5400000"/>
-            <a:ext cx="2879640" cy="311400"/>
+            <a:ext cx="2879280" cy="311400"/>
           </a:xfrm>
           <a:prstGeom prst="rect">
             <a:avLst/>
@@ -1979,7 +1979,7 @@
         <p:spPr>
           <a:xfrm>
             <a:off x="3420000" y="5400000"/>
-            <a:ext cx="3239640" cy="311400"/>
+            <a:ext cx="3239280" cy="311400"/>
           </a:xfrm>
           <a:prstGeom prst="rect">
             <a:avLst/>
@@ -2057,7 +2057,7 @@
         <p:spPr>
           <a:xfrm>
             <a:off x="9180000" y="5262480"/>
-            <a:ext cx="719640" cy="274680"/>
+            <a:ext cx="719280" cy="274680"/>
           </a:xfrm>
           <a:prstGeom prst="rect">
             <a:avLst/>
@@ -2100,7 +2100,7 @@
                 <a:tab algn="l" pos="0"/>
               </a:tabLst>
             </a:pPr>
-            <a:fld id="{334437E0-B720-4DAF-B768-E2E640FA0523}" type="slidenum">
+            <a:fld id="{C094B33D-7273-49A9-A076-B67BAD0E855F}" type="slidenum">
               <a:rPr lang="en-GB" sz="1800" b="1" u="none" strike="noStrike">
                 <a:solidFill>
                   <a:srgbClr val="ffffff"/>
@@ -2185,7 +2185,7 @@
         <p:spPr>
           <a:xfrm>
             <a:off x="360000" y="225720"/>
-            <a:ext cx="9359640" cy="719640"/>
+            <a:ext cx="9359280" cy="719280"/>
           </a:xfrm>
           <a:prstGeom prst="rect">
             <a:avLst/>
@@ -2244,7 +2244,7 @@
         <p:spPr>
           <a:xfrm>
             <a:off x="360000" y="1485000"/>
-            <a:ext cx="9359640" cy="3779640"/>
+            <a:ext cx="9359280" cy="3779280"/>
           </a:xfrm>
           <a:prstGeom prst="rect">
             <a:avLst/>
@@ -2450,7 +2450,7 @@
         <p:txBody>
           <a:bodyPr/>
           <a:p>
-            <a:fld id="{70F8DDF2-FA8B-4AAB-8B76-ADEF5BDDFB88}" type="slidenum">
+            <a:fld id="{8196882F-397D-46D7-A711-D77016E8E9C9}" type="slidenum">
               <a:t>1</a:t>
             </a:fld>
           </a:p>
@@ -2499,7 +2499,7 @@
         <p:spPr>
           <a:xfrm>
             <a:off x="360000" y="225720"/>
-            <a:ext cx="9359640" cy="718560"/>
+            <a:ext cx="9359280" cy="718200"/>
           </a:xfrm>
           <a:prstGeom prst="rect">
             <a:avLst/>
@@ -2558,7 +2558,7 @@
         <p:spPr>
           <a:xfrm>
             <a:off x="360000" y="1485000"/>
-            <a:ext cx="9359640" cy="494640"/>
+            <a:ext cx="9359280" cy="494280"/>
           </a:xfrm>
           <a:prstGeom prst="rect">
             <a:avLst/>
@@ -2604,7 +2604,7 @@
               </a:solidFill>
               <a:effectLst/>
               <a:uFillTx/>
-              <a:latin typeface="Times New Roman"/>
+              <a:latin typeface="Arial"/>
             </a:endParaRPr>
           </a:p>
         </p:txBody>
@@ -2622,7 +2622,7 @@
         <p:spPr>
           <a:xfrm>
             <a:off x="339480" y="1980000"/>
-            <a:ext cx="5600160" cy="3004920"/>
+            <a:ext cx="5599800" cy="3004560"/>
           </a:xfrm>
           <a:prstGeom prst="rect">
             <a:avLst/>
@@ -2641,8 +2641,8 @@
         </p:nvSpPr>
         <p:spPr>
           <a:xfrm>
-            <a:off x="6120000" y="1980000"/>
-            <a:ext cx="3779640" cy="2159640"/>
+            <a:off x="5760000" y="1980000"/>
+            <a:ext cx="4139280" cy="2159280"/>
           </a:xfrm>
           <a:prstGeom prst="rect">
             <a:avLst/>
@@ -2685,6 +2685,7 @@
                 <a:effectLst/>
                 <a:uFillTx/>
                 <a:latin typeface="Times New Roman"/>
+                <a:ea typeface="DejaVu Sans"/>
               </a:rPr>
               <a:t>Separation is done to prevent inrush current (motors) interfering from logic components</a:t>
             </a:r>
@@ -2713,7 +2714,7 @@
         <p:txBody>
           <a:bodyPr/>
           <a:p>
-            <a:fld id="{8937386F-DA06-44A5-A2CB-1ED2E569FDB0}" type="slidenum">
+            <a:fld id="{11BC9BA0-31D6-4509-AE7D-12CE6934C801}" type="slidenum">
               <a:t>10</a:t>
             </a:fld>
           </a:p>
@@ -2762,7 +2763,7 @@
         <p:spPr>
           <a:xfrm>
             <a:off x="360000" y="225720"/>
-            <a:ext cx="9359640" cy="718560"/>
+            <a:ext cx="9359280" cy="718200"/>
           </a:xfrm>
           <a:prstGeom prst="rect">
             <a:avLst/>
@@ -2821,7 +2822,7 @@
         <p:spPr>
           <a:xfrm>
             <a:off x="360000" y="1305000"/>
-            <a:ext cx="9359640" cy="494640"/>
+            <a:ext cx="9359280" cy="494280"/>
           </a:xfrm>
           <a:prstGeom prst="rect">
             <a:avLst/>
@@ -2886,7 +2887,7 @@
         <p:spPr>
           <a:xfrm>
             <a:off x="360360" y="1800360"/>
-            <a:ext cx="5399280" cy="1619280"/>
+            <a:ext cx="5398920" cy="1618920"/>
           </a:xfrm>
           <a:prstGeom prst="rect">
             <a:avLst/>
@@ -2906,7 +2907,7 @@
         <p:spPr>
           <a:xfrm>
             <a:off x="5760000" y="1800000"/>
-            <a:ext cx="4139640" cy="3419640"/>
+            <a:ext cx="4139280" cy="3419280"/>
           </a:xfrm>
           <a:prstGeom prst="rect">
             <a:avLst/>
@@ -2949,6 +2950,7 @@
                 <a:effectLst/>
                 <a:uFillTx/>
                 <a:latin typeface="Times New Roman"/>
+                <a:ea typeface="DejaVu Sans"/>
               </a:rPr>
               <a:t>Correct polarity connection allows connection to the output node</a:t>
             </a:r>
@@ -2984,6 +2986,7 @@
                 <a:effectLst/>
                 <a:uFillTx/>
                 <a:latin typeface="Times New Roman"/>
+                <a:ea typeface="DejaVu Sans"/>
               </a:rPr>
               <a:t>Wrong polarity connection does not allow connection to the output node</a:t>
             </a:r>
@@ -3012,7 +3015,7 @@
         <p:spPr>
           <a:xfrm>
             <a:off x="360360" y="3600000"/>
-            <a:ext cx="5399280" cy="1691640"/>
+            <a:ext cx="5398920" cy="1691280"/>
           </a:xfrm>
           <a:prstGeom prst="rect">
             <a:avLst/>
@@ -3037,7 +3040,7 @@
         <p:txBody>
           <a:bodyPr/>
           <a:p>
-            <a:fld id="{EAF54884-DB2B-4E63-84B0-57F34D476EEB}" type="slidenum">
+            <a:fld id="{5AD9DA9C-E131-4D21-8DD3-C2DA784AAFB9}" type="slidenum">
               <a:t>11</a:t>
             </a:fld>
           </a:p>
@@ -3086,7 +3089,7 @@
         <p:spPr>
           <a:xfrm>
             <a:off x="360000" y="225720"/>
-            <a:ext cx="9359640" cy="718560"/>
+            <a:ext cx="9359280" cy="718200"/>
           </a:xfrm>
           <a:prstGeom prst="rect">
             <a:avLst/>
@@ -3145,7 +3148,7 @@
         <p:spPr>
           <a:xfrm>
             <a:off x="360000" y="1305000"/>
-            <a:ext cx="9359640" cy="494640"/>
+            <a:ext cx="9359280" cy="494280"/>
           </a:xfrm>
           <a:prstGeom prst="rect">
             <a:avLst/>
@@ -3191,7 +3194,7 @@
               </a:solidFill>
               <a:effectLst/>
               <a:uFillTx/>
-              <a:latin typeface="Times New Roman"/>
+              <a:latin typeface="Arial"/>
             </a:endParaRPr>
           </a:p>
         </p:txBody>
@@ -3209,7 +3212,7 @@
         <p:spPr>
           <a:xfrm>
             <a:off x="469800" y="1920240"/>
-            <a:ext cx="5469840" cy="2939400"/>
+            <a:ext cx="5469480" cy="2939040"/>
           </a:xfrm>
           <a:prstGeom prst="rect">
             <a:avLst/>
@@ -3229,7 +3232,7 @@
         <p:spPr>
           <a:xfrm>
             <a:off x="6120000" y="1980000"/>
-            <a:ext cx="3779640" cy="1979640"/>
+            <a:ext cx="3779280" cy="1979280"/>
           </a:xfrm>
           <a:prstGeom prst="rect">
             <a:avLst/>
@@ -3272,6 +3275,7 @@
                 <a:effectLst/>
                 <a:uFillTx/>
                 <a:latin typeface="Times New Roman"/>
+                <a:ea typeface="DejaVu Sans"/>
               </a:rPr>
               <a:t>ULN2003A driver circuit was designed to drive stepper motors and simulation went as expected</a:t>
             </a:r>
@@ -3300,7 +3304,7 @@
         <p:txBody>
           <a:bodyPr/>
           <a:p>
-            <a:fld id="{9A51F20F-6E62-4FB5-A021-483C25654E7B}" type="slidenum">
+            <a:fld id="{BFC16DE4-6248-462D-B433-52F65D133384}" type="slidenum">
               <a:t>12</a:t>
             </a:fld>
           </a:p>
@@ -3349,7 +3353,7 @@
         <p:spPr>
           <a:xfrm>
             <a:off x="360000" y="225720"/>
-            <a:ext cx="9359640" cy="718560"/>
+            <a:ext cx="9359280" cy="718200"/>
           </a:xfrm>
           <a:prstGeom prst="rect">
             <a:avLst/>
@@ -3408,7 +3412,7 @@
         <p:spPr>
           <a:xfrm>
             <a:off x="360000" y="1485000"/>
-            <a:ext cx="9359640" cy="3779640"/>
+            <a:ext cx="9359280" cy="3779280"/>
           </a:xfrm>
           <a:prstGeom prst="rect">
             <a:avLst/>
@@ -3508,7 +3512,7 @@
         <p:txBody>
           <a:bodyPr/>
           <a:p>
-            <a:fld id="{0252A40F-3874-4218-A9D8-21B68433E916}" type="slidenum">
+            <a:fld id="{F1E24978-8250-48B2-B2AD-9A457DA37E27}" type="slidenum">
               <a:t>13</a:t>
             </a:fld>
           </a:p>
@@ -3557,7 +3561,7 @@
         <p:spPr>
           <a:xfrm>
             <a:off x="360000" y="225720"/>
-            <a:ext cx="9359640" cy="718560"/>
+            <a:ext cx="9359280" cy="718200"/>
           </a:xfrm>
           <a:prstGeom prst="rect">
             <a:avLst/>
@@ -3616,7 +3620,7 @@
         <p:spPr>
           <a:xfrm>
             <a:off x="360000" y="1485000"/>
-            <a:ext cx="9359640" cy="3779640"/>
+            <a:ext cx="9359280" cy="3779280"/>
           </a:xfrm>
           <a:prstGeom prst="rect">
             <a:avLst/>
@@ -3654,7 +3658,7 @@
                 <a:uFillTx/>
                 <a:latin typeface="Times New Roman"/>
               </a:rPr>
-              <a:t>The project aims to ease ID card issuance process for registered students by developing a prototype of an automated system.</a:t>
+              <a:t>The project aims to ease ID card issuance process for registered students by developing a prototype of an automated system</a:t>
             </a:r>
             <a:endParaRPr lang="en-GB" sz="2800" b="0" u="none" strike="noStrike">
               <a:solidFill>
@@ -3689,7 +3693,7 @@
                 <a:uFillTx/>
                 <a:latin typeface="Times New Roman"/>
               </a:rPr>
-              <a:t>Registered students will be able to return their expired cards, and retrieve their valid ID cards  for that particular academic year.</a:t>
+              <a:t>Registered students will be able to return their expired cards, and retrieve their valid ID cards  for that particular academic year</a:t>
             </a:r>
             <a:endParaRPr lang="en-GB" sz="2800" b="0" u="none" strike="noStrike">
               <a:solidFill>
@@ -3716,7 +3720,7 @@
         <p:txBody>
           <a:bodyPr/>
           <a:p>
-            <a:fld id="{DFF18C57-5D88-4877-B86F-24AE11E4A531}" type="slidenum">
+            <a:fld id="{DCEA3018-34E5-484C-8FCF-75ED8E136A7D}" type="slidenum">
               <a:t>2</a:t>
             </a:fld>
           </a:p>
@@ -3765,7 +3769,7 @@
         <p:spPr>
           <a:xfrm>
             <a:off x="360000" y="225720"/>
-            <a:ext cx="9359640" cy="718560"/>
+            <a:ext cx="9359280" cy="718200"/>
           </a:xfrm>
           <a:prstGeom prst="rect">
             <a:avLst/>
@@ -3824,7 +3828,7 @@
         <p:spPr>
           <a:xfrm>
             <a:off x="360000" y="4140000"/>
-            <a:ext cx="9359640" cy="1124640"/>
+            <a:ext cx="9359280" cy="1124280"/>
           </a:xfrm>
           <a:prstGeom prst="rect">
             <a:avLst/>
@@ -3862,7 +3866,7 @@
                 <a:uFillTx/>
                 <a:latin typeface="Times New Roman"/>
               </a:rPr>
-              <a:t>With high student volumes, narrow administrative working window leads to long queues and delayed distribution.</a:t>
+              <a:t>With high student volumes, narrow administrative working window leads to long queues and delayed distribution</a:t>
             </a:r>
             <a:endParaRPr lang="en-GB" sz="2400" b="0" u="none" strike="noStrike">
               <a:solidFill>
@@ -3888,7 +3892,7 @@
         <p:spPr>
           <a:xfrm>
             <a:off x="900000" y="1260000"/>
-            <a:ext cx="7919640" cy="3056040"/>
+            <a:ext cx="7919280" cy="3055680"/>
           </a:xfrm>
           <a:prstGeom prst="rect">
             <a:avLst/>
@@ -3913,7 +3917,7 @@
         <p:txBody>
           <a:bodyPr/>
           <a:p>
-            <a:fld id="{C0263FAD-63F9-4214-93E4-2FBD024C3153}" type="slidenum">
+            <a:fld id="{F771673D-1812-43D2-B7AE-6032556D7278}" type="slidenum">
               <a:t>3</a:t>
             </a:fld>
           </a:p>
@@ -3962,7 +3966,7 @@
         <p:spPr>
           <a:xfrm>
             <a:off x="360000" y="225720"/>
-            <a:ext cx="9359640" cy="718560"/>
+            <a:ext cx="9359280" cy="718200"/>
           </a:xfrm>
           <a:prstGeom prst="rect">
             <a:avLst/>
@@ -4021,7 +4025,7 @@
         <p:spPr>
           <a:xfrm>
             <a:off x="0" y="1260000"/>
-            <a:ext cx="9359640" cy="539640"/>
+            <a:ext cx="9359280" cy="539280"/>
           </a:xfrm>
           <a:prstGeom prst="rect">
             <a:avLst/>
@@ -4079,7 +4083,7 @@
         <p:spPr>
           <a:xfrm>
             <a:off x="540000" y="1800000"/>
-            <a:ext cx="3779640" cy="1439640"/>
+            <a:ext cx="3779280" cy="1439280"/>
           </a:xfrm>
           <a:prstGeom prst="flowChartAlternateProcess">
             <a:avLst/>
@@ -4201,7 +4205,7 @@
         <p:spPr>
           <a:xfrm>
             <a:off x="540000" y="3420000"/>
-            <a:ext cx="3779640" cy="1619640"/>
+            <a:ext cx="3779280" cy="1619280"/>
           </a:xfrm>
           <a:prstGeom prst="flowChartAlternateProcess">
             <a:avLst/>
@@ -4323,7 +4327,7 @@
         <p:spPr>
           <a:xfrm>
             <a:off x="5040000" y="1800000"/>
-            <a:ext cx="3779640" cy="1439640"/>
+            <a:ext cx="3779280" cy="1439280"/>
           </a:xfrm>
           <a:prstGeom prst="flowChartAlternateProcess">
             <a:avLst/>
@@ -4445,7 +4449,7 @@
         <p:spPr>
           <a:xfrm>
             <a:off x="5040000" y="3420000"/>
-            <a:ext cx="3779640" cy="1619640"/>
+            <a:ext cx="3779280" cy="1619280"/>
           </a:xfrm>
           <a:prstGeom prst="flowChartAlternateProcess">
             <a:avLst/>
@@ -4572,7 +4576,7 @@
         <p:txBody>
           <a:bodyPr/>
           <a:p>
-            <a:fld id="{617D7274-93A2-435F-8D4E-9A34A197AC36}" type="slidenum">
+            <a:fld id="{67A3899E-1E9F-4287-8C6B-8D0870F8CEF5}" type="slidenum">
               <a:t>4</a:t>
             </a:fld>
           </a:p>
@@ -4621,7 +4625,7 @@
         <p:spPr>
           <a:xfrm>
             <a:off x="360000" y="225720"/>
-            <a:ext cx="9359640" cy="718560"/>
+            <a:ext cx="9359280" cy="718200"/>
           </a:xfrm>
           <a:prstGeom prst="rect">
             <a:avLst/>
@@ -4680,7 +4684,7 @@
         <p:spPr>
           <a:xfrm>
             <a:off x="360000" y="1260000"/>
-            <a:ext cx="9359640" cy="3779640"/>
+            <a:ext cx="9359280" cy="3779280"/>
           </a:xfrm>
           <a:prstGeom prst="rect">
             <a:avLst/>
@@ -4928,7 +4932,7 @@
         <p:txBody>
           <a:bodyPr/>
           <a:p>
-            <a:fld id="{548B3677-B242-4F52-8140-032A082791CA}" type="slidenum">
+            <a:fld id="{FA803275-D688-4630-9218-A0E815BB47D9}" type="slidenum">
               <a:t>5</a:t>
             </a:fld>
           </a:p>
@@ -4977,7 +4981,7 @@
         <p:spPr>
           <a:xfrm>
             <a:off x="360000" y="225720"/>
-            <a:ext cx="9359640" cy="718560"/>
+            <a:ext cx="9359280" cy="718200"/>
           </a:xfrm>
           <a:prstGeom prst="rect">
             <a:avLst/>
@@ -5036,7 +5040,7 @@
         <p:spPr>
           <a:xfrm>
             <a:off x="360000" y="4140000"/>
-            <a:ext cx="9359640" cy="1124640"/>
+            <a:ext cx="9359280" cy="1124280"/>
           </a:xfrm>
           <a:prstGeom prst="rect">
             <a:avLst/>
@@ -5074,7 +5078,7 @@
                 <a:uFillTx/>
                 <a:latin typeface="Times New Roman"/>
               </a:rPr>
-              <a:t>High – level controller manages authentication, UI, database and computer vision while low – level controller manages real – time controls and sensor integration.</a:t>
+              <a:t>High – level controller manages authentication, UI, database and computer vision while low – level controller manages real – time controls and sensor integration</a:t>
             </a:r>
             <a:endParaRPr lang="en-GB" sz="2200" b="0" u="none" strike="noStrike">
               <a:solidFill>
@@ -5100,7 +5104,7 @@
         <p:spPr>
           <a:xfrm>
             <a:off x="180000" y="1257480"/>
-            <a:ext cx="9539640" cy="2882160"/>
+            <a:ext cx="9539280" cy="2881800"/>
           </a:xfrm>
           <a:prstGeom prst="rect">
             <a:avLst/>
@@ -5125,7 +5129,7 @@
         <p:txBody>
           <a:bodyPr/>
           <a:p>
-            <a:fld id="{859A5480-EEC9-43D8-85CC-27FF4C8A17F2}" type="slidenum">
+            <a:fld id="{8B2A437C-66C2-4224-B050-16E5EDC06CCC}" type="slidenum">
               <a:t>6</a:t>
             </a:fld>
           </a:p>
@@ -5174,7 +5178,7 @@
         <p:spPr>
           <a:xfrm>
             <a:off x="360000" y="225720"/>
-            <a:ext cx="9359640" cy="718560"/>
+            <a:ext cx="9359280" cy="718200"/>
           </a:xfrm>
           <a:prstGeom prst="rect">
             <a:avLst/>
@@ -5233,7 +5237,7 @@
         <p:spPr>
           <a:xfrm>
             <a:off x="1082880" y="1080000"/>
-            <a:ext cx="8276760" cy="4349880"/>
+            <a:ext cx="8276400" cy="4349520"/>
           </a:xfrm>
           <a:prstGeom prst="rect">
             <a:avLst/>
@@ -5258,7 +5262,7 @@
         <p:txBody>
           <a:bodyPr/>
           <a:p>
-            <a:fld id="{F5705930-1EF2-4638-84E6-D7C5A0562D7B}" type="slidenum">
+            <a:fld id="{9EA6F57E-651F-4C58-AD7F-1F68CB673F98}" type="slidenum">
               <a:t>7</a:t>
             </a:fld>
           </a:p>
@@ -5307,7 +5311,7 @@
         <p:spPr>
           <a:xfrm>
             <a:off x="360000" y="225720"/>
-            <a:ext cx="9359640" cy="718560"/>
+            <a:ext cx="9359280" cy="718200"/>
           </a:xfrm>
           <a:prstGeom prst="rect">
             <a:avLst/>
@@ -5366,7 +5370,7 @@
         <p:spPr>
           <a:xfrm>
             <a:off x="180000" y="1260000"/>
-            <a:ext cx="3760560" cy="4139640"/>
+            <a:ext cx="3760200" cy="4139280"/>
           </a:xfrm>
           <a:prstGeom prst="rect">
             <a:avLst/>
@@ -5390,7 +5394,7 @@
         <p:spPr>
           <a:xfrm>
             <a:off x="4320000" y="1260000"/>
-            <a:ext cx="5652000" cy="4224960"/>
+            <a:ext cx="5651640" cy="4224600"/>
           </a:xfrm>
           <a:prstGeom prst="rect">
             <a:avLst/>
@@ -5415,7 +5419,7 @@
         <p:txBody>
           <a:bodyPr/>
           <a:p>
-            <a:fld id="{6B571FA4-9866-4811-A676-CD2E8E893AEE}" type="slidenum">
+            <a:fld id="{B585E79B-5A4A-4375-B61D-8D2CA4CEA805}" type="slidenum">
               <a:t>8</a:t>
             </a:fld>
           </a:p>
@@ -5464,7 +5468,7 @@
         <p:spPr>
           <a:xfrm>
             <a:off x="360000" y="225720"/>
-            <a:ext cx="9359640" cy="718560"/>
+            <a:ext cx="9359280" cy="718200"/>
           </a:xfrm>
           <a:prstGeom prst="rect">
             <a:avLst/>
@@ -5523,7 +5527,7 @@
         <p:spPr>
           <a:xfrm>
             <a:off x="0" y="1186920"/>
-            <a:ext cx="10079280" cy="1332720"/>
+            <a:ext cx="10078920" cy="1332360"/>
           </a:xfrm>
           <a:prstGeom prst="rect">
             <a:avLst/>
@@ -5548,7 +5552,7 @@
         <p:spPr>
           <a:xfrm>
             <a:off x="156240" y="2776680"/>
-            <a:ext cx="2723400" cy="1902960"/>
+            <a:ext cx="2723040" cy="1902600"/>
           </a:xfrm>
           <a:prstGeom prst="rect">
             <a:avLst/>
@@ -5572,7 +5576,7 @@
         <p:spPr>
           <a:xfrm>
             <a:off x="3240000" y="2774520"/>
-            <a:ext cx="3020760" cy="1905120"/>
+            <a:ext cx="3020400" cy="1904760"/>
           </a:xfrm>
           <a:prstGeom prst="rect">
             <a:avLst/>
@@ -5596,7 +5600,7 @@
         <p:spPr>
           <a:xfrm>
             <a:off x="6621120" y="3240000"/>
-            <a:ext cx="3278520" cy="1103400"/>
+            <a:ext cx="3278160" cy="1103040"/>
           </a:xfrm>
           <a:prstGeom prst="rect">
             <a:avLst/>
@@ -5616,7 +5620,7 @@
         <p:spPr>
           <a:xfrm>
             <a:off x="2880000" y="3600000"/>
-            <a:ext cx="359640" cy="179640"/>
+            <a:ext cx="359280" cy="179280"/>
           </a:xfrm>
           <a:prstGeom prst="rightArrow">
             <a:avLst>
@@ -5671,7 +5675,7 @@
         <p:spPr>
           <a:xfrm>
             <a:off x="6261120" y="3600000"/>
-            <a:ext cx="359640" cy="179640"/>
+            <a:ext cx="359280" cy="179280"/>
           </a:xfrm>
           <a:prstGeom prst="rightArrow">
             <a:avLst>
@@ -5731,7 +5735,7 @@
         <p:txBody>
           <a:bodyPr/>
           <a:p>
-            <a:fld id="{6CB4BD5D-9324-4C89-AE5C-97F7BB2D3A07}" type="slidenum">
+            <a:fld id="{6AB31D03-028A-4FDB-B15A-8B44DEE464AD}" type="slidenum">
               <a:t>9</a:t>
             </a:fld>
           </a:p>

</xml_diff>